<commit_message>
Update manager deck with screenshots of the refreshed UI
Recaptured all app screenshots from the refreshed release build (demo
database only), refreshed callouts describing the new layout, and rebuilt
the PPTX and PDF. Package validation passed; all slides rendered and checked.

Co-Authored-By: Claude Opus 5.5 <noreply@anthropic.com>
Claude-Session: https://claude.ai/code/session_01HWrBGcfhNjcmenpQ6crSxK
</commit_message>
<xml_diff>
--- a/docs/manager-presentation-2026-10-19/final/MachineCare_Manager_Review_Final.pptx
+++ b/docs/manager-presentation-2026-10-19/final/MachineCare_Manager_Review_Final.pptx
@@ -127,7 +127,7 @@
   <p:extLst>
     <p:ext uri="{521415D9-36F7-43E2-AB2F-B90AF26B5E84}">
       <p14:sectionLst xmlns:p14="http://schemas.microsoft.com/office/powerpoint/2010/main">
-        <p14:section name="Opening" id="{e4c6a19c-0a67-cc5e-5066-fe588a5f5512}">
+        <p14:section name="Opening" id="{ff53eb69-9d2c-404b-6b59-646b954d8b1c}">
           <p14:sldIdLst>
             <p14:sldId id="256"/>
             <p14:sldId id="257"/>
@@ -135,7 +135,7 @@
             <p14:sldId id="259"/>
           </p14:sldIdLst>
         </p14:section>
-        <p14:section name="App walkthrough" id="{38d7c73c-4e7a-1ae2-68c4-5189142d5f8d}">
+        <p14:section name="App walkthrough" id="{aaf85987-ac69-55ad-c6b6-453e997b16a6}">
           <p14:sldIdLst>
             <p14:sldId id="260"/>
             <p14:sldId id="261"/>
@@ -149,7 +149,7 @@
             <p14:sldId id="269"/>
           </p14:sldIdLst>
         </p14:section>
-        <p14:section name="Path to production" id="{c57b4fd2-0b57-8335-d07f-5a3d0ffa1749}">
+        <p14:section name="Path to production" id="{81b1a6ab-6983-ac56-b612-5dd1d2a39ded}">
           <p14:sldIdLst>
             <p14:sldId id="270"/>
             <p14:sldId id="271"/>
@@ -158,7 +158,7 @@
             <p14:sldId id="274"/>
           </p14:sldIdLst>
         </p14:section>
-        <p14:section name="Appendix" id="{b0af7d72-48c7-9950-c63e-47edb3b758bb}">
+        <p14:section name="Appendix" id="{8b14f3ee-fb4b-b266-9dad-1f208e6a7ae2}">
           <p14:sldIdLst>
             <p14:sldId id="275"/>
             <p14:sldId id="276"/>
@@ -3661,7 +3661,7 @@
                   <a:schemeClr val="accent1"/>
                 </a:solidFill>
               </a:rPr>
-              <a:t>In this queue</a:t>
+              <a:t>Grouped by what to do next</a:t>
             </a:r>
             <a:endParaRPr lang="en-US" sz="2000" dirty="0"/>
           </a:p>
@@ -22596,7 +22596,7 @@
                   <a:schemeClr val="tx2"/>
                 </a:solidFill>
               </a:rPr>
-              <a:t>Counters</a:t>
+              <a:t>Attention cards</a:t>
             </a:r>
             <a:endParaRPr lang="en-US" sz="1400" dirty="0"/>
           </a:p>
@@ -22613,7 +22613,7 @@
                   <a:schemeClr val="accent5"/>
                 </a:solidFill>
               </a:rPr>
-              <a:t>Machines, low-stock SKUs, pending approvals, spend, alerts, open reorders</a:t>
+              <a:t>Turn amber or red when action is needed; click one to jump to that page</a:t>
             </a:r>
             <a:endParaRPr lang="en-US" sz="1400" dirty="0"/>
           </a:p>
@@ -22725,7 +22725,7 @@
                   <a:schemeClr val="accent5"/>
                 </a:solidFill>
               </a:rPr>
-              <a:t>Operating, maintenance, stopped and retired at a glance</a:t>
+              <a:t>Operating, maintenance, stopped and retired, each with colour and icon</a:t>
             </a:r>
             <a:endParaRPr lang="en-US" sz="1400" dirty="0"/>
           </a:p>
@@ -22837,7 +22837,7 @@
                   <a:schemeClr val="accent5"/>
                 </a:solidFill>
               </a:rPr>
-              <a:t>Parts below threshold, with available versus threshold</a:t>
+              <a:t>Parts at or below their reorder level, with a stock bar</a:t>
             </a:r>
             <a:endParaRPr lang="en-US" sz="1400" dirty="0"/>
           </a:p>
@@ -23891,7 +23891,7 @@
                   <a:schemeClr val="accent5"/>
                 </a:solidFill>
               </a:rPr>
-              <a:t>Approved work reserves stock; availability never goes below zero</a:t>
+              <a:t>Three clear tiles plus a bar marking the reorder level</a:t>
             </a:r>
             <a:endParaRPr lang="en-US" sz="1400" dirty="0"/>
           </a:p>
@@ -24115,7 +24115,7 @@
                   <a:schemeClr val="accent5"/>
                 </a:solidFill>
               </a:rPr>
-              <a:t>A tag marks stock, prices, bins and intervals as placeholders</a:t>
+              <a:t>A blue tag marks stock, prices, bins and intervals as placeholders</a:t>
             </a:r>
             <a:endParaRPr lang="en-US" sz="1400" dirty="0"/>
           </a:p>

</xml_diff>

<commit_message>
Show and use supplier lead time; add budget comparison slides and cost model
Lead time: inventory fact in days/weeks/months, long-lead pill, arrival
estimate in low-stock notice and reorder dialog, expected arrival and
overdue-delivery notice on reorders (reorder rows now include lead_days).
Budget: editable xlsx (vendor quote vs in-house assumptions) and two new
deck slides; recaptured screenshots. Backend 141 OK, Flutter 48 passed,
analyze clean.

Co-Authored-By: Claude Opus 5.5 <noreply@anthropic.com>
Claude-Session: https://claude.ai/code/session_01HWrBGcfhNjcmenpQ6crSxK
</commit_message>
<xml_diff>
--- a/docs/manager-presentation-2026-10-19/final/MachineCare_Manager_Review_Final.pptx
+++ b/docs/manager-presentation-2026-10-19/final/MachineCare_Manager_Review_Final.pptx
@@ -26,9 +26,11 @@
     <p:sldId id="274" r:id="rId20"/>
     <p:sldId id="275" r:id="rId21"/>
     <p:sldId id="276" r:id="rId22"/>
+    <p:sldId id="277" r:id="rId23"/>
+    <p:sldId id="278" r:id="rId24"/>
   </p:sldIdLst>
   <p:notesMasterIdLst>
-    <p:notesMasterId r:id="rId23"/>
+    <p:notesMasterId r:id="rId25"/>
   </p:notesMasterIdLst>
   <p:sldSz cx="12192000" cy="6858000"/>
   <p:notesSz cx="6858000" cy="12192000"/>
@@ -127,7 +129,7 @@
   <p:extLst>
     <p:ext uri="{521415D9-36F7-43E2-AB2F-B90AF26B5E84}">
       <p14:sectionLst xmlns:p14="http://schemas.microsoft.com/office/powerpoint/2010/main">
-        <p14:section name="Opening" id="{ff53eb69-9d2c-404b-6b59-646b954d8b1c}">
+        <p14:section name="Opening" id="{df07487f-7fd2-52f5-e401-eb1599e9f1f4}">
           <p14:sldIdLst>
             <p14:sldId id="256"/>
             <p14:sldId id="257"/>
@@ -135,7 +137,7 @@
             <p14:sldId id="259"/>
           </p14:sldIdLst>
         </p14:section>
-        <p14:section name="App walkthrough" id="{aaf85987-ac69-55ad-c6b6-453e997b16a6}">
+        <p14:section name="App walkthrough" id="{179cbd3e-4361-4064-f4e4-36e59f56025f}">
           <p14:sldIdLst>
             <p14:sldId id="260"/>
             <p14:sldId id="261"/>
@@ -149,19 +151,21 @@
             <p14:sldId id="269"/>
           </p14:sldIdLst>
         </p14:section>
-        <p14:section name="Path to production" id="{81b1a6ab-6983-ac56-b612-5dd1d2a39ded}">
+        <p14:section name="Path to production" id="{550afc0c-402f-a825-05d2-5a22b67e56db}">
           <p14:sldIdLst>
             <p14:sldId id="270"/>
             <p14:sldId id="271"/>
             <p14:sldId id="272"/>
             <p14:sldId id="273"/>
             <p14:sldId id="274"/>
+            <p14:sldId id="275"/>
+            <p14:sldId id="276"/>
           </p14:sldIdLst>
         </p14:section>
-        <p14:section name="Appendix" id="{8b14f3ee-fb4b-b266-9dad-1f208e6a7ae2}">
+        <p14:section name="Appendix" id="{730a50e8-a3d4-3835-c64f-29eca011461d}">
           <p14:sldIdLst>
-            <p14:sldId id="275"/>
-            <p14:sldId id="276"/>
+            <p14:sldId id="277"/>
+            <p14:sldId id="278"/>
           </p14:sldIdLst>
         </p14:section>
       </p14:sectionLst>
@@ -171,6 +175,399 @@
     </p:ext>
   </p:extLst>
 </p:presentation>
+</file>
+
+<file path=ppt/charts/chart1.xml><?xml version="1.0" encoding="utf-8"?>
+<c:chartSpace xmlns:c="http://schemas.openxmlformats.org/drawingml/2006/chart" xmlns:a="http://schemas.openxmlformats.org/drawingml/2006/main" xmlns:r="http://schemas.openxmlformats.org/officeDocument/2006/relationships">
+  <c:date1904 val="0"/>
+  <c:roundedCorners val="1"/>
+  <c:chart>
+    <c:title>
+      <c:tx>
+        <c:rich>
+          <a:bodyPr/>
+          <a:lstStyle/>
+          <a:p>
+            <a:pPr>
+              <a:defRPr sz="1400" b="0" i="0" u="none" strike="noStrike">
+                <a:solidFill>
+                  <a:srgbClr val="0F2A3A"/>
+                </a:solidFill>
+                <a:latin typeface="+mn-lt"/>
+              </a:defRPr>
+            </a:pPr>
+            <a:r>
+              <a:rPr sz="1400" b="0" i="0" u="none" strike="noStrike">
+                <a:solidFill>
+                  <a:srgbClr val="0F2A3A"/>
+                </a:solidFill>
+                <a:latin typeface="+mn-lt"/>
+              </a:rPr>
+              <a:t>Cumulative cost (US$)</a:t>
+            </a:r>
+          </a:p>
+        </c:rich>
+      </c:tx>
+      <c:layout/>
+      <c:overlay val="0"/>
+    </c:title>
+    <c:autoTitleDeleted val="0"/>
+    <c:plotArea>
+      <c:layout/>
+      <c:barChart>
+        <c:barDir val="col"/>
+        <c:grouping val="clustered"/>
+        <c:varyColors val="0"/>
+        <c:ser>
+          <c:idx val="0"/>
+          <c:order val="0"/>
+          <c:tx>
+            <c:strRef>
+              <c:f>Sheet1!$B$1</c:f>
+              <c:strCache>
+                <c:ptCount val="1"/>
+                <c:pt idx="0">
+                  <c:v>Outside vendor</c:v>
+                </c:pt>
+              </c:strCache>
+            </c:strRef>
+          </c:tx>
+          <c:spPr>
+            <a:solidFill>
+              <a:srgbClr val="C2410C"/>
+            </a:solidFill>
+            <a:effectLst/>
+          </c:spPr>
+          <c:invertIfNegative val="0"/>
+          <c:dLbls>
+            <c:numFmt formatCode="$#,##0,&quot;k&quot;" sourceLinked="0"/>
+            <c:txPr>
+              <a:bodyPr/>
+              <a:lstStyle/>
+              <a:p>
+                <a:pPr>
+                  <a:defRPr b="0" i="0" strike="noStrike" sz="1000" u="none">
+                    <a:solidFill>
+                      <a:srgbClr val="0F2A3A"/>
+                    </a:solidFill>
+                    <a:latin typeface="+mn-lt"/>
+                  </a:defRPr>
+                </a:pPr>
+              </a:p>
+            </c:txPr>
+            <c:showLegendKey val="0"/>
+            <c:showVal val="1"/>
+            <c:showCatName val="0"/>
+            <c:showSerName val="0"/>
+            <c:showPercent val="0"/>
+            <c:showBubbleSize val="0"/>
+            <c:showLeaderLines val="0"/>
+          </c:dLbls>
+          <c:cat>
+            <c:multiLvlStrRef>
+              <c:f>Sheet1!$A$2:$A$6</c:f>
+              <c:multiLvlStrCache>
+                <c:ptCount val="5"/>
+                <c:lvl>
+                  <c:pt idx="0">
+                    <c:v>Year 1</c:v>
+                  </c:pt>
+                  <c:pt idx="1">
+                    <c:v>Year 2</c:v>
+                  </c:pt>
+                  <c:pt idx="2">
+                    <c:v>Year 3</c:v>
+                  </c:pt>
+                  <c:pt idx="3">
+                    <c:v>Year 4</c:v>
+                  </c:pt>
+                  <c:pt idx="4">
+                    <c:v>Year 5</c:v>
+                  </c:pt>
+                </c:lvl>
+              </c:multiLvlStrCache>
+            </c:multiLvlStrRef>
+          </c:cat>
+          <c:val>
+            <c:numRef>
+              <c:f>Sheet1!$B$2:$B$6</c:f>
+              <c:numCache>
+                <c:formatCode>General</c:formatCode>
+                <c:ptCount val="5"/>
+                <c:pt idx="0">
+                  <c:v>52880</c:v>
+                </c:pt>
+                <c:pt idx="1">
+                  <c:v>90080</c:v>
+                </c:pt>
+                <c:pt idx="2">
+                  <c:v>127280</c:v>
+                </c:pt>
+                <c:pt idx="3">
+                  <c:v>164480</c:v>
+                </c:pt>
+                <c:pt idx="4">
+                  <c:v>201680</c:v>
+                </c:pt>
+              </c:numCache>
+            </c:numRef>
+          </c:val>
+        </c:ser>
+        <c:ser>
+          <c:idx val="1"/>
+          <c:order val="1"/>
+          <c:tx>
+            <c:strRef>
+              <c:f>Sheet1!$C$1</c:f>
+              <c:strCache>
+                <c:ptCount val="1"/>
+                <c:pt idx="0">
+                  <c:v>MachineCare (in-house)</c:v>
+                </c:pt>
+              </c:strCache>
+            </c:strRef>
+          </c:tx>
+          <c:spPr>
+            <a:solidFill>
+              <a:srgbClr val="00695C"/>
+            </a:solidFill>
+            <a:effectLst/>
+          </c:spPr>
+          <c:invertIfNegative val="0"/>
+          <c:dLbls>
+            <c:numFmt formatCode="$#,##0,&quot;k&quot;" sourceLinked="0"/>
+            <c:txPr>
+              <a:bodyPr/>
+              <a:lstStyle/>
+              <a:p>
+                <a:pPr>
+                  <a:defRPr b="0" i="0" strike="noStrike" sz="1000" u="none">
+                    <a:solidFill>
+                      <a:srgbClr val="0F2A3A"/>
+                    </a:solidFill>
+                    <a:latin typeface="+mn-lt"/>
+                  </a:defRPr>
+                </a:pPr>
+              </a:p>
+            </c:txPr>
+            <c:showLegendKey val="0"/>
+            <c:showVal val="1"/>
+            <c:showCatName val="0"/>
+            <c:showSerName val="0"/>
+            <c:showPercent val="0"/>
+            <c:showBubbleSize val="0"/>
+            <c:showLeaderLines val="0"/>
+          </c:dLbls>
+          <c:cat>
+            <c:multiLvlStrRef>
+              <c:f>Sheet1!$A$2:$A$6</c:f>
+              <c:multiLvlStrCache>
+                <c:ptCount val="5"/>
+                <c:lvl>
+                  <c:pt idx="0">
+                    <c:v>Year 1</c:v>
+                  </c:pt>
+                  <c:pt idx="1">
+                    <c:v>Year 2</c:v>
+                  </c:pt>
+                  <c:pt idx="2">
+                    <c:v>Year 3</c:v>
+                  </c:pt>
+                  <c:pt idx="3">
+                    <c:v>Year 4</c:v>
+                  </c:pt>
+                  <c:pt idx="4">
+                    <c:v>Year 5</c:v>
+                  </c:pt>
+                </c:lvl>
+              </c:multiLvlStrCache>
+            </c:multiLvlStrRef>
+          </c:cat>
+          <c:val>
+            <c:numRef>
+              <c:f>Sheet1!$C$2:$C$6</c:f>
+              <c:numCache>
+                <c:formatCode>General</c:formatCode>
+                <c:ptCount val="5"/>
+                <c:pt idx="0">
+                  <c:v>29600</c:v>
+                </c:pt>
+                <c:pt idx="1">
+                  <c:v>39120</c:v>
+                </c:pt>
+                <c:pt idx="2">
+                  <c:v>48640</c:v>
+                </c:pt>
+                <c:pt idx="3">
+                  <c:v>58160</c:v>
+                </c:pt>
+                <c:pt idx="4">
+                  <c:v>67680</c:v>
+                </c:pt>
+              </c:numCache>
+            </c:numRef>
+          </c:val>
+        </c:ser>
+        <c:dLbls>
+          <c:numFmt formatCode="$#,##0,&quot;k&quot;" sourceLinked="0"/>
+          <c:txPr>
+            <a:bodyPr/>
+            <a:lstStyle/>
+            <a:p>
+              <a:pPr>
+                <a:defRPr b="0" i="0" strike="noStrike" sz="1000" u="none">
+                  <a:solidFill>
+                    <a:srgbClr val="0F2A3A"/>
+                  </a:solidFill>
+                  <a:latin typeface="+mn-lt"/>
+                </a:defRPr>
+              </a:pPr>
+            </a:p>
+          </c:txPr>
+          <c:showLegendKey val="0"/>
+          <c:showVal val="1"/>
+          <c:showCatName val="0"/>
+          <c:showSerName val="0"/>
+          <c:showPercent val="0"/>
+          <c:showBubbleSize val="0"/>
+          <c:showLeaderLines val="0"/>
+        </c:dLbls>
+        <c:gapWidth val="60"/>
+        <c:overlap val="0"/>
+        <c:axId val="2094734554"/>
+        <c:axId val="2094734552"/>
+        <c:axId val="2094734556"/>
+      </c:barChart>
+      <c:catAx>
+        <c:axId val="2094734554"/>
+        <c:scaling>
+          <c:orientation val="minMax"/>
+        </c:scaling>
+        <c:delete val="0"/>
+        <c:axPos val="b"/>
+        <c:numFmt formatCode="General" sourceLinked="1"/>
+        <c:majorTickMark val="out"/>
+        <c:minorTickMark val="none"/>
+        <c:tickLblPos val="low"/>
+        <c:spPr>
+          <a:ln w="12700" cap="flat">
+            <a:solidFill>
+              <a:srgbClr val="888888"/>
+            </a:solidFill>
+            <a:prstDash val="solid"/>
+            <a:round/>
+          </a:ln>
+        </c:spPr>
+        <c:txPr>
+          <a:bodyPr/>
+          <a:lstStyle/>
+          <a:p>
+            <a:pPr>
+              <a:defRPr sz="1200" b="0" i="0" u="none" strike="noStrike">
+                <a:solidFill>
+                  <a:srgbClr val="0F2A3A"/>
+                </a:solidFill>
+                <a:latin typeface="+mn-lt"/>
+              </a:defRPr>
+            </a:pPr>
+            <a:endParaRPr lang="en-US"/>
+          </a:p>
+        </c:txPr>
+        <c:crossAx val="2094734552"/>
+        <c:crosses val="autoZero"/>
+        <c:auto val="1"/>
+        <c:lblAlgn val="ctr"/>
+        <c:noMultiLvlLbl val="1"/>
+      </c:catAx>
+      <c:valAx>
+        <c:axId val="2094734552"/>
+        <c:scaling>
+          <c:orientation val="minMax"/>
+        </c:scaling>
+        <c:delete val="0"/>
+        <c:axPos val="l"/>
+        <c:majorGridlines>
+          <c:spPr>
+            <a:ln w="9525" cap="flat">
+              <a:solidFill>
+                <a:srgbClr val="E3EAED"/>
+              </a:solidFill>
+              <a:prstDash val="solid"/>
+              <a:round/>
+            </a:ln>
+          </c:spPr>
+        </c:majorGridlines>
+        <c:numFmt formatCode="$#,##0,&quot;k&quot;" sourceLinked="0"/>
+        <c:majorTickMark val="out"/>
+        <c:minorTickMark val="none"/>
+        <c:tickLblPos val="nextTo"/>
+        <c:spPr>
+          <a:ln w="12700" cap="flat">
+            <a:solidFill>
+              <a:srgbClr val="888888"/>
+            </a:solidFill>
+            <a:prstDash val="solid"/>
+            <a:round/>
+          </a:ln>
+        </c:spPr>
+        <c:txPr>
+          <a:bodyPr/>
+          <a:lstStyle/>
+          <a:p>
+            <a:pPr>
+              <a:defRPr sz="1100" b="0" i="0" u="none" strike="noStrike">
+                <a:solidFill>
+                  <a:srgbClr val="5B7083"/>
+                </a:solidFill>
+                <a:latin typeface="+mn-lt"/>
+              </a:defRPr>
+            </a:pPr>
+            <a:endParaRPr lang="en-US"/>
+          </a:p>
+        </c:txPr>
+        <c:crossAx val="2094734554"/>
+        <c:crosses val="autoZero"/>
+        <c:crossBetween val="between"/>
+      </c:valAx>
+      <c:spPr>
+        <a:noFill/>
+        <a:ln>
+          <a:noFill/>
+        </a:ln>
+        <a:effectLst/>
+      </c:spPr>
+    </c:plotArea>
+    <c:legend>
+      <c:legendPos val="b"/>
+      <c:overlay val="0"/>
+      <c:txPr>
+        <a:bodyPr/>
+        <a:lstStyle/>
+        <a:p>
+          <a:pPr>
+            <a:defRPr sz="1200">
+              <a:latin typeface="+mn-lt"/>
+              <a:cs typeface="+mn-lt"/>
+            </a:defRPr>
+          </a:pPr>
+          <a:endParaRPr lang="en-US"/>
+        </a:p>
+      </c:txPr>
+    </c:legend>
+    <c:plotVisOnly val="1"/>
+    <c:dispBlanksAs val="span"/>
+  </c:chart>
+  <c:spPr>
+    <a:noFill/>
+    <a:ln>
+      <a:noFill/>
+    </a:ln>
+    <a:effectLst/>
+  </c:spPr>
+  <c:externalData r:id="rId1">
+    <c:autoUpdate val="0"/>
+  </c:externalData>
+</c:chartSpace>
 </file>
 
 <file path=ppt/notesMasters/notesMaster1.xml><?xml version="1.0" encoding="utf-8"?>
@@ -1448,7 +1845,7 @@
           <a:p>
             <a:r>
               <a:rPr lang="en-US" dirty="0"/>
-              <a:t>Close with three concrete requests. Do not commit to a production date until the gates have owners and scope.</a:t>
+              <a:t>Outside vendor: 62 licences at $50 per user per month is $37,200 a year, plus the $10,000 one-time installation. Year 1 is $52,880 including $5,680 of our own time for stock counts and training, which we need with either option. Five-year total $201,680. MachineCare: no licence fees. Year 1 is $29,600 (hardening, deployment and an independent security review, plus the same data and training effort); then about $9,520 a year for hosting and an internal owner's support time. Five-year total $67,680, a saving of about $134,000. The vendor price includes their support and updates; with MachineCare we carry that responsibility ourselves, which is why support hours are budgeted every year. Replace the yellow assumptions in the spreadsheet with our real labour rate and quotes before approval.</a:t>
             </a:r>
             <a:endParaRPr lang="en-US" dirty="0"/>
           </a:p>
@@ -1624,7 +2021,7 @@
           <a:p>
             <a:r>
               <a:rPr lang="en-US" dirty="0"/>
-              <a:t>References exactly as supplied by maintenance. Spare quantities in the demo are illustrative and separate from installed quantities.</a:t>
+              <a:t>Year 1 for MachineCare is $29,600; each later year about $9,520. The biggest unknowns are our internal hourly rate and the security review quote. Stock counting and training are needed whichever system we choose, so they appear in both totals. The main trade-off: a vendor provides support and updates; with MachineCare an internal owner does, which is budgeted at 4 hours a week.</a:t>
             </a:r>
             <a:endParaRPr lang="en-US" dirty="0"/>
           </a:p>
@@ -1712,7 +2109,7 @@
           <a:p>
             <a:r>
               <a:rPr lang="en-US" dirty="0"/>
-              <a:t>Identifiers kept verbatim pending nameplate confirmation. Catalog entries for safety components are not an inspection or certification.</a:t>
+              <a:t>Close with three concrete requests. Do not commit to a production date until the gates have owners and scope.</a:t>
             </a:r>
             <a:endParaRPr lang="en-US" dirty="0"/>
           </a:p>
@@ -1736,6 +2133,182 @@
             <a:fld id="{F7021451-1387-4CA6-816F-3879F97B5CBC}" type="slidenum">
               <a:rPr lang="en-US"/>
               <a:t>21</a:t>
+            </a:fld>
+            <a:endParaRPr lang="en-US"/>
+          </a:p>
+        </p:txBody>
+      </p:sp>
+    </p:spTree>
+    <p:extLst>
+      <p:ext uri="{BB962C8B-B14F-4D97-AF65-F5344CB8AC3E}">
+        <p14:creationId xmlns:p14="http://schemas.microsoft.com/office/powerpoint/2010/main" val="1024086991"/>
+      </p:ext>
+    </p:extLst>
+  </p:cSld>
+  <p:clrMapOvr>
+    <a:masterClrMapping/>
+  </p:clrMapOvr>
+</p:notes>
+</file>
+
+<file path=ppt/notesSlides/notesSlide22.xml><?xml version="1.0" encoding="utf-8"?>
+<p:notes xmlns:a="http://schemas.openxmlformats.org/drawingml/2006/main" xmlns:r="http://schemas.openxmlformats.org/officeDocument/2006/relationships" xmlns:p="http://schemas.openxmlformats.org/presentationml/2006/main">
+  <p:cSld>
+    <p:spTree>
+      <p:nvGrpSpPr>
+        <p:cNvPr id="1" name=""/>
+        <p:cNvGrpSpPr/>
+        <p:nvPr/>
+      </p:nvGrpSpPr>
+      <p:grpSpPr>
+        <a:xfrm>
+          <a:off x="0" y="0"/>
+          <a:ext cx="0" cy="0"/>
+          <a:chOff x="0" y="0"/>
+          <a:chExt cx="0" cy="0"/>
+        </a:xfrm>
+      </p:grpSpPr>
+      <p:sp>
+        <p:nvSpPr>
+          <p:cNvPr id="2" name="Slide Image Placeholder 1"/>
+          <p:cNvSpPr>
+            <a:spLocks noGrp="1" noRot="1" noChangeAspect="1"/>
+          </p:cNvSpPr>
+          <p:nvPr>
+            <p:ph type="sldImg"/>
+          </p:nvPr>
+        </p:nvSpPr>
+        <p:spPr/>
+      </p:sp>
+      <p:sp>
+        <p:nvSpPr>
+          <p:cNvPr id="3" name="Notes Placeholder 2"/>
+          <p:cNvSpPr>
+            <a:spLocks noGrp="1"/>
+          </p:cNvSpPr>
+          <p:nvPr>
+            <p:ph type="body" idx="1"/>
+          </p:nvPr>
+        </p:nvSpPr>
+        <p:spPr/>
+        <p:txBody>
+          <a:bodyPr/>
+          <a:lstStyle/>
+          <a:p>
+            <a:r>
+              <a:rPr lang="en-US" dirty="0"/>
+              <a:t>References exactly as supplied by maintenance. Spare quantities in the demo are illustrative and separate from installed quantities.</a:t>
+            </a:r>
+            <a:endParaRPr lang="en-US" dirty="0"/>
+          </a:p>
+        </p:txBody>
+      </p:sp>
+      <p:sp>
+        <p:nvSpPr>
+          <p:cNvPr id="4" name="Slide Number Placeholder 3"/>
+          <p:cNvSpPr>
+            <a:spLocks noGrp="1"/>
+          </p:cNvSpPr>
+          <p:nvPr>
+            <p:ph type="sldNum" sz="quarter" idx="10"/>
+          </p:nvPr>
+        </p:nvSpPr>
+        <p:spPr/>
+        <p:txBody>
+          <a:bodyPr/>
+          <a:lstStyle/>
+          <a:p>
+            <a:fld id="{F7021451-1387-4CA6-816F-3879F97B5CBC}" type="slidenum">
+              <a:rPr lang="en-US"/>
+              <a:t>22</a:t>
+            </a:fld>
+            <a:endParaRPr lang="en-US"/>
+          </a:p>
+        </p:txBody>
+      </p:sp>
+    </p:spTree>
+    <p:extLst>
+      <p:ext uri="{BB962C8B-B14F-4D97-AF65-F5344CB8AC3E}">
+        <p14:creationId xmlns:p14="http://schemas.microsoft.com/office/powerpoint/2010/main" val="1024086991"/>
+      </p:ext>
+    </p:extLst>
+  </p:cSld>
+  <p:clrMapOvr>
+    <a:masterClrMapping/>
+  </p:clrMapOvr>
+</p:notes>
+</file>
+
+<file path=ppt/notesSlides/notesSlide23.xml><?xml version="1.0" encoding="utf-8"?>
+<p:notes xmlns:a="http://schemas.openxmlformats.org/drawingml/2006/main" xmlns:r="http://schemas.openxmlformats.org/officeDocument/2006/relationships" xmlns:p="http://schemas.openxmlformats.org/presentationml/2006/main">
+  <p:cSld>
+    <p:spTree>
+      <p:nvGrpSpPr>
+        <p:cNvPr id="1" name=""/>
+        <p:cNvGrpSpPr/>
+        <p:nvPr/>
+      </p:nvGrpSpPr>
+      <p:grpSpPr>
+        <a:xfrm>
+          <a:off x="0" y="0"/>
+          <a:ext cx="0" cy="0"/>
+          <a:chOff x="0" y="0"/>
+          <a:chExt cx="0" cy="0"/>
+        </a:xfrm>
+      </p:grpSpPr>
+      <p:sp>
+        <p:nvSpPr>
+          <p:cNvPr id="2" name="Slide Image Placeholder 1"/>
+          <p:cNvSpPr>
+            <a:spLocks noGrp="1" noRot="1" noChangeAspect="1"/>
+          </p:cNvSpPr>
+          <p:nvPr>
+            <p:ph type="sldImg"/>
+          </p:nvPr>
+        </p:nvSpPr>
+        <p:spPr/>
+      </p:sp>
+      <p:sp>
+        <p:nvSpPr>
+          <p:cNvPr id="3" name="Notes Placeholder 2"/>
+          <p:cNvSpPr>
+            <a:spLocks noGrp="1"/>
+          </p:cNvSpPr>
+          <p:nvPr>
+            <p:ph type="body" idx="1"/>
+          </p:nvPr>
+        </p:nvSpPr>
+        <p:spPr/>
+        <p:txBody>
+          <a:bodyPr/>
+          <a:lstStyle/>
+          <a:p>
+            <a:r>
+              <a:rPr lang="en-US" dirty="0"/>
+              <a:t>Identifiers kept verbatim pending nameplate confirmation. Catalog entries for safety components are not an inspection or certification.</a:t>
+            </a:r>
+            <a:endParaRPr lang="en-US" dirty="0"/>
+          </a:p>
+        </p:txBody>
+      </p:sp>
+      <p:sp>
+        <p:nvSpPr>
+          <p:cNvPr id="4" name="Slide Number Placeholder 3"/>
+          <p:cNvSpPr>
+            <a:spLocks noGrp="1"/>
+          </p:cNvSpPr>
+          <p:nvPr>
+            <p:ph type="sldNum" sz="quarter" idx="10"/>
+          </p:nvPr>
+        </p:nvSpPr>
+        <p:spPr/>
+        <p:txBody>
+          <a:bodyPr/>
+          <a:lstStyle/>
+          <a:p>
+            <a:fld id="{F7021451-1387-4CA6-816F-3879F97B5CBC}" type="slidenum">
+              <a:rPr lang="en-US"/>
+              <a:t>23</a:t>
             </a:fld>
             <a:endParaRPr lang="en-US"/>
           </a:p>
@@ -4975,7 +5548,7 @@
                   <a:schemeClr val="tx2"/>
                 </a:solidFill>
               </a:rPr>
-              <a:t>Built-in protection</a:t>
+              <a:t>Expected arrival</a:t>
             </a:r>
             <a:endParaRPr lang="en-US" sz="1400" dirty="0"/>
           </a:p>
@@ -4992,7 +5565,7 @@
                   <a:schemeClr val="accent5"/>
                 </a:solidFill>
               </a:rPr>
-              <a:t>Duplicate delivery references and over-receipts are rejected</a:t>
+              <a:t>Order date + supplier lead time; late deliveries turn red. Duplicates and over-receipts are rejected</a:t>
             </a:r>
             <a:endParaRPr lang="en-US" sz="1400" dirty="0"/>
           </a:p>
@@ -11921,7 +12494,7 @@
         </p:nvSpPr>
         <p:spPr>
           <a:xfrm>
-            <a:off x="548640" y="457200"/>
+            <a:off x="548640" y="292608"/>
             <a:ext cx="11064240" cy="274320"/>
           </a:xfrm>
           <a:prstGeom prst="rect">
@@ -11940,10 +12513,10 @@
             <a:r>
               <a:rPr lang="en-US" sz="1200" b="1" spc="200" kern="0" dirty="0">
                 <a:solidFill>
-                  <a:schemeClr val="accent2"/>
+                  <a:schemeClr val="accent1"/>
                 </a:solidFill>
               </a:rPr>
-              <a:t>THE DECISION</a:t>
+              <a:t>BUDGET · 5-YEAR VIEW</a:t>
             </a:r>
             <a:endParaRPr lang="en-US" sz="1200" dirty="0"/>
           </a:p>
@@ -11959,8 +12532,8 @@
         </p:nvSpPr>
         <p:spPr>
           <a:xfrm>
-            <a:off x="548640" y="777240"/>
-            <a:ext cx="11064240" cy="914400"/>
+            <a:off x="548640" y="548640"/>
+            <a:ext cx="11064240" cy="685800"/>
           </a:xfrm>
           <a:prstGeom prst="rect">
             <a:avLst/>
@@ -11976,83 +12549,77 @@
               <a:buNone/>
             </a:pPr>
             <a:r>
-              <a:rPr lang="en-US" sz="3600" b="1" dirty="0">
-                <a:solidFill>
-                  <a:schemeClr val="bg1"/>
+              <a:rPr lang="en-US" sz="3200" b="1" dirty="0">
+                <a:solidFill>
+                  <a:schemeClr val="tx2"/>
                 </a:solidFill>
               </a:rPr>
-              <a:t>Approve a focused validation pilot</a:t>
+              <a:t>MachineCare costs about a third of the outside system</a:t>
             </a:r>
-            <a:endParaRPr lang="en-US" sz="3600" dirty="0"/>
-          </a:p>
-        </p:txBody>
-      </p:sp>
-      <p:sp>
-        <p:nvSpPr>
-          <p:cNvPr id="4" name="Shape 2"/>
+            <a:endParaRPr lang="en-US" sz="3200" dirty="0"/>
+          </a:p>
+        </p:txBody>
+      </p:sp>
+      <p:graphicFrame>
+        <p:nvGraphicFramePr>
+          <p:cNvPr id="4" name="Chart 0" descr=""/>
+          <p:cNvGraphicFramePr/>
+          <p:nvPr/>
+        </p:nvGraphicFramePr>
+        <p:xfrm>
+          <a:off x="548640" y="1508760"/>
+          <a:ext cx="6858000" cy="4526280"/>
+        </p:xfrm>
+        <a:graphic xmlns:a="http://schemas.openxmlformats.org/drawingml/2006/main">
+          <a:graphicData uri="http://schemas.openxmlformats.org/drawingml/2006/chart">
+            <c:chart xmlns:c="http://schemas.openxmlformats.org/drawingml/2006/chart" r:id="rId1"/>
+          </a:graphicData>
+        </a:graphic>
+      </p:graphicFrame>
+      <p:sp>
+        <p:nvSpPr>
+          <p:cNvPr id="5" name="Shape 2"/>
           <p:cNvSpPr/>
           <p:nvPr/>
         </p:nvSpPr>
         <p:spPr>
           <a:xfrm>
-            <a:off x="548640" y="2103120"/>
-            <a:ext cx="731520" cy="731520"/>
-          </a:xfrm>
-          <a:prstGeom prst="ellipse">
-            <a:avLst/>
+            <a:off x="7772400" y="1508760"/>
+            <a:ext cx="3840480" cy="1371600"/>
+          </a:xfrm>
+          <a:prstGeom prst="roundRect">
+            <a:avLst>
+              <a:gd name="adj" fmla="val 6667"/>
+            </a:avLst>
           </a:prstGeom>
           <a:solidFill>
-            <a:schemeClr val="accent1"/>
+            <a:schemeClr val="bg1"/>
           </a:solidFill>
-          <a:ln/>
-        </p:spPr>
-      </p:sp>
-      <p:sp>
-        <p:nvSpPr>
-          <p:cNvPr id="5" name="Text 3"/>
+          <a:ln w="9525">
+            <a:solidFill>
+              <a:srgbClr val="D5E0E3"/>
+            </a:solidFill>
+            <a:prstDash val="solid"/>
+          </a:ln>
+          <a:effectLst>
+            <a:outerShdw sx="100000" sy="100000" kx="0" ky="0" algn="bl" rotWithShape="0" blurRad="101600" dist="25400" dir="5400000">
+              <a:srgbClr val="0F2A3A">
+                <a:alpha val="18000"/>
+              </a:srgbClr>
+            </a:outerShdw>
+          </a:effectLst>
+        </p:spPr>
+      </p:sp>
+      <p:sp>
+        <p:nvSpPr>
+          <p:cNvPr id="6" name="Text 3"/>
           <p:cNvSpPr txBox="1"/>
           <p:nvPr/>
         </p:nvSpPr>
         <p:spPr>
           <a:xfrm>
-            <a:off x="548640" y="2103120"/>
-            <a:ext cx="731520" cy="731520"/>
-          </a:xfrm>
-          <a:prstGeom prst="rect">
-            <a:avLst/>
-          </a:prstGeom>
-          <a:noFill/>
-          <a:ln/>
-        </p:spPr>
-        <p:txBody>
-          <a:bodyPr wrap="square" lIns="0" tIns="0" rIns="0" bIns="0" rtlCol="0" anchor="ctr"/>
-          <a:lstStyle/>
-          <a:p>
-            <a:pPr algn="ctr" indent="0" marL="0">
-              <a:buNone/>
-            </a:pPr>
-            <a:r>
-              <a:rPr lang="en-US" sz="2400" b="1" dirty="0">
-                <a:solidFill>
-                  <a:schemeClr val="bg1"/>
-                </a:solidFill>
-              </a:rPr>
-              <a:t>1</a:t>
-            </a:r>
-            <a:endParaRPr lang="en-US" sz="2400" dirty="0"/>
-          </a:p>
-        </p:txBody>
-      </p:sp>
-      <p:sp>
-        <p:nvSpPr>
-          <p:cNvPr id="6" name="Text 4"/>
-          <p:cNvSpPr txBox="1"/>
-          <p:nvPr/>
-        </p:nvSpPr>
-        <p:spPr>
-          <a:xfrm>
-            <a:off x="1554480" y="2057400"/>
-            <a:ext cx="6858000" cy="914400"/>
+            <a:off x="8001000" y="1618488"/>
+            <a:ext cx="3474720" cy="274320"/>
           </a:xfrm>
           <a:prstGeom prst="rect">
             <a:avLst/>
@@ -12068,97 +12635,63 @@
               <a:buNone/>
             </a:pPr>
             <a:r>
-              <a:rPr lang="en-US" sz="2200" b="1" dirty="0">
-                <a:solidFill>
-                  <a:schemeClr val="bg1"/>
+              <a:rPr lang="en-US" sz="1300" b="1" dirty="0">
+                <a:solidFill>
+                  <a:schemeClr val="accent5"/>
                 </a:solidFill>
               </a:rPr>
-              <a:t>Choose one validated line</a:t>
+              <a:t>Outside vendor · 5 years</a:t>
             </a:r>
-            <a:endParaRPr lang="en-US" sz="2200" dirty="0"/>
-          </a:p>
+            <a:endParaRPr lang="en-US" sz="1300" dirty="0"/>
+          </a:p>
+        </p:txBody>
+      </p:sp>
+      <p:sp>
+        <p:nvSpPr>
+          <p:cNvPr id="7" name="Text 4"/>
+          <p:cNvSpPr txBox="1"/>
+          <p:nvPr/>
+        </p:nvSpPr>
+        <p:spPr>
+          <a:xfrm>
+            <a:off x="8001000" y="1892808"/>
+            <a:ext cx="3474720" cy="502920"/>
+          </a:xfrm>
+          <a:prstGeom prst="rect">
+            <a:avLst/>
+          </a:prstGeom>
+          <a:noFill/>
+          <a:ln/>
+        </p:spPr>
+        <p:txBody>
+          <a:bodyPr wrap="square" lIns="0" tIns="0" rIns="0" bIns="0" rtlCol="0" anchor="ctr"/>
+          <a:lstStyle/>
           <a:p>
             <a:pPr indent="0" marL="0">
               <a:buNone/>
             </a:pPr>
             <a:r>
-              <a:rPr lang="en-US" sz="1500" dirty="0">
-                <a:solidFill>
-                  <a:schemeClr val="accent6"/>
+              <a:rPr lang="en-US" sz="2800" b="1" dirty="0">
+                <a:solidFill>
+                  <a:schemeClr val="accent4"/>
                 </a:solidFill>
               </a:rPr>
-              <a:t>Where we count real stock and run the full workflow</a:t>
+              <a:t>$201,680</a:t>
             </a:r>
-            <a:endParaRPr lang="en-US" sz="2200" dirty="0"/>
-          </a:p>
-        </p:txBody>
-      </p:sp>
-      <p:sp>
-        <p:nvSpPr>
-          <p:cNvPr id="7" name="Shape 5"/>
-          <p:cNvSpPr/>
-          <p:nvPr/>
-        </p:nvSpPr>
-        <p:spPr>
-          <a:xfrm>
-            <a:off x="548640" y="3291840"/>
-            <a:ext cx="731520" cy="731520"/>
-          </a:xfrm>
-          <a:prstGeom prst="ellipse">
-            <a:avLst/>
-          </a:prstGeom>
-          <a:solidFill>
-            <a:schemeClr val="accent1"/>
-          </a:solidFill>
-          <a:ln/>
-        </p:spPr>
-      </p:sp>
-      <p:sp>
-        <p:nvSpPr>
-          <p:cNvPr id="8" name="Text 6"/>
+            <a:endParaRPr lang="en-US" sz="2800" dirty="0"/>
+          </a:p>
+        </p:txBody>
+      </p:sp>
+      <p:sp>
+        <p:nvSpPr>
+          <p:cNvPr id="8" name="Text 5"/>
           <p:cNvSpPr txBox="1"/>
           <p:nvPr/>
         </p:nvSpPr>
         <p:spPr>
           <a:xfrm>
-            <a:off x="548640" y="3291840"/>
-            <a:ext cx="731520" cy="731520"/>
-          </a:xfrm>
-          <a:prstGeom prst="rect">
-            <a:avLst/>
-          </a:prstGeom>
-          <a:noFill/>
-          <a:ln/>
-        </p:spPr>
-        <p:txBody>
-          <a:bodyPr wrap="square" lIns="0" tIns="0" rIns="0" bIns="0" rtlCol="0" anchor="ctr"/>
-          <a:lstStyle/>
-          <a:p>
-            <a:pPr algn="ctr" indent="0" marL="0">
-              <a:buNone/>
-            </a:pPr>
-            <a:r>
-              <a:rPr lang="en-US" sz="2400" b="1" dirty="0">
-                <a:solidFill>
-                  <a:schemeClr val="bg1"/>
-                </a:solidFill>
-              </a:rPr>
-              <a:t>2</a:t>
-            </a:r>
-            <a:endParaRPr lang="en-US" sz="2400" dirty="0"/>
-          </a:p>
-        </p:txBody>
-      </p:sp>
-      <p:sp>
-        <p:nvSpPr>
-          <p:cNvPr id="9" name="Text 7"/>
-          <p:cNvSpPr txBox="1"/>
-          <p:nvPr/>
-        </p:nvSpPr>
-        <p:spPr>
-          <a:xfrm>
-            <a:off x="1554480" y="3246120"/>
-            <a:ext cx="6858000" cy="914400"/>
+            <a:off x="8001000" y="2395728"/>
+            <a:ext cx="3474720" cy="411480"/>
           </a:xfrm>
           <a:prstGeom prst="rect">
             <a:avLst/>
@@ -12174,97 +12707,97 @@
               <a:buNone/>
             </a:pPr>
             <a:r>
-              <a:rPr lang="en-US" sz="2200" b="1" dirty="0">
-                <a:solidFill>
-                  <a:schemeClr val="bg1"/>
+              <a:rPr lang="en-US" sz="1100" dirty="0">
+                <a:solidFill>
+                  <a:schemeClr val="accent5"/>
                 </a:solidFill>
               </a:rPr>
-              <a:t>Name a data owner and an IT reviewer</a:t>
+              <a:t>$50/user/month × 62 users + $10,000 installation</a:t>
             </a:r>
-            <a:endParaRPr lang="en-US" sz="2200" dirty="0"/>
-          </a:p>
+            <a:endParaRPr lang="en-US" sz="1100" dirty="0"/>
+          </a:p>
+        </p:txBody>
+      </p:sp>
+      <p:sp>
+        <p:nvSpPr>
+          <p:cNvPr id="9" name="Shape 6"/>
+          <p:cNvSpPr/>
+          <p:nvPr/>
+        </p:nvSpPr>
+        <p:spPr>
+          <a:xfrm>
+            <a:off x="7772400" y="3044952"/>
+            <a:ext cx="3840480" cy="1371600"/>
+          </a:xfrm>
+          <a:prstGeom prst="roundRect">
+            <a:avLst>
+              <a:gd name="adj" fmla="val 6667"/>
+            </a:avLst>
+          </a:prstGeom>
+          <a:solidFill>
+            <a:schemeClr val="bg1"/>
+          </a:solidFill>
+          <a:ln w="9525">
+            <a:solidFill>
+              <a:srgbClr val="D5E0E3"/>
+            </a:solidFill>
+            <a:prstDash val="solid"/>
+          </a:ln>
+          <a:effectLst>
+            <a:outerShdw sx="100000" sy="100000" kx="0" ky="0" algn="bl" rotWithShape="0" blurRad="101600" dist="25400" dir="5400000">
+              <a:srgbClr val="0F2A3A">
+                <a:alpha val="18000"/>
+              </a:srgbClr>
+            </a:outerShdw>
+          </a:effectLst>
+        </p:spPr>
+      </p:sp>
+      <p:sp>
+        <p:nvSpPr>
+          <p:cNvPr id="10" name="Text 7"/>
+          <p:cNvSpPr txBox="1"/>
+          <p:nvPr/>
+        </p:nvSpPr>
+        <p:spPr>
+          <a:xfrm>
+            <a:off x="8001000" y="3154680"/>
+            <a:ext cx="3474720" cy="274320"/>
+          </a:xfrm>
+          <a:prstGeom prst="rect">
+            <a:avLst/>
+          </a:prstGeom>
+          <a:noFill/>
+          <a:ln/>
+        </p:spPr>
+        <p:txBody>
+          <a:bodyPr wrap="square" lIns="0" tIns="0" rIns="0" bIns="0" rtlCol="0" anchor="ctr"/>
+          <a:lstStyle/>
           <a:p>
             <a:pPr indent="0" marL="0">
               <a:buNone/>
             </a:pPr>
             <a:r>
-              <a:rPr lang="en-US" sz="1500" dirty="0">
-                <a:solidFill>
-                  <a:schemeClr val="accent6"/>
+              <a:rPr lang="en-US" sz="1300" b="1" dirty="0">
+                <a:solidFill>
+                  <a:schemeClr val="accent5"/>
                 </a:solidFill>
               </a:rPr>
-              <a:t>Maintenance and IT/security owners for the production gates</a:t>
+              <a:t>MachineCare · 5 years</a:t>
             </a:r>
-            <a:endParaRPr lang="en-US" sz="2200" dirty="0"/>
-          </a:p>
-        </p:txBody>
-      </p:sp>
-      <p:sp>
-        <p:nvSpPr>
-          <p:cNvPr id="10" name="Shape 8"/>
-          <p:cNvSpPr/>
-          <p:nvPr/>
-        </p:nvSpPr>
-        <p:spPr>
-          <a:xfrm>
-            <a:off x="548640" y="4480560"/>
-            <a:ext cx="731520" cy="731520"/>
-          </a:xfrm>
-          <a:prstGeom prst="ellipse">
-            <a:avLst/>
-          </a:prstGeom>
-          <a:solidFill>
-            <a:schemeClr val="accent1"/>
-          </a:solidFill>
-          <a:ln/>
-        </p:spPr>
-      </p:sp>
-      <p:sp>
-        <p:nvSpPr>
-          <p:cNvPr id="11" name="Text 9"/>
+            <a:endParaRPr lang="en-US" sz="1300" dirty="0"/>
+          </a:p>
+        </p:txBody>
+      </p:sp>
+      <p:sp>
+        <p:nvSpPr>
+          <p:cNvPr id="11" name="Text 8"/>
           <p:cNvSpPr txBox="1"/>
           <p:nvPr/>
         </p:nvSpPr>
         <p:spPr>
           <a:xfrm>
-            <a:off x="548640" y="4480560"/>
-            <a:ext cx="731520" cy="731520"/>
-          </a:xfrm>
-          <a:prstGeom prst="rect">
-            <a:avLst/>
-          </a:prstGeom>
-          <a:noFill/>
-          <a:ln/>
-        </p:spPr>
-        <p:txBody>
-          <a:bodyPr wrap="square" lIns="0" tIns="0" rIns="0" bIns="0" rtlCol="0" anchor="ctr"/>
-          <a:lstStyle/>
-          <a:p>
-            <a:pPr algn="ctr" indent="0" marL="0">
-              <a:buNone/>
-            </a:pPr>
-            <a:r>
-              <a:rPr lang="en-US" sz="2400" b="1" dirty="0">
-                <a:solidFill>
-                  <a:schemeClr val="bg1"/>
-                </a:solidFill>
-              </a:rPr>
-              <a:t>3</a:t>
-            </a:r>
-            <a:endParaRPr lang="en-US" sz="2400" dirty="0"/>
-          </a:p>
-        </p:txBody>
-      </p:sp>
-      <p:sp>
-        <p:nvSpPr>
-          <p:cNvPr id="12" name="Text 10"/>
-          <p:cNvSpPr txBox="1"/>
-          <p:nvPr/>
-        </p:nvSpPr>
-        <p:spPr>
-          <a:xfrm>
-            <a:off x="1554480" y="4434840"/>
-            <a:ext cx="6858000" cy="914400"/>
+            <a:off x="8001000" y="3429000"/>
+            <a:ext cx="3474720" cy="502920"/>
           </a:xfrm>
           <a:prstGeom prst="rect">
             <a:avLst/>
@@ -12280,55 +12813,87 @@
               <a:buNone/>
             </a:pPr>
             <a:r>
-              <a:rPr lang="en-US" sz="2200" b="1" dirty="0">
-                <a:solidFill>
-                  <a:schemeClr val="bg1"/>
+              <a:rPr lang="en-US" sz="2800" b="1" dirty="0">
+                <a:solidFill>
+                  <a:schemeClr val="accent1"/>
                 </a:solidFill>
               </a:rPr>
-              <a:t>Agree acceptance measures</a:t>
+              <a:t>$67,680</a:t>
             </a:r>
-            <a:endParaRPr lang="en-US" sz="2200" dirty="0"/>
-          </a:p>
+            <a:endParaRPr lang="en-US" sz="2800" dirty="0"/>
+          </a:p>
+        </p:txBody>
+      </p:sp>
+      <p:sp>
+        <p:nvSpPr>
+          <p:cNvPr id="12" name="Text 9"/>
+          <p:cNvSpPr txBox="1"/>
+          <p:nvPr/>
+        </p:nvSpPr>
+        <p:spPr>
+          <a:xfrm>
+            <a:off x="8001000" y="3931920"/>
+            <a:ext cx="3474720" cy="411480"/>
+          </a:xfrm>
+          <a:prstGeom prst="rect">
+            <a:avLst/>
+          </a:prstGeom>
+          <a:noFill/>
+          <a:ln/>
+        </p:spPr>
+        <p:txBody>
+          <a:bodyPr wrap="square" lIns="0" tIns="0" rIns="0" bIns="0" rtlCol="0" anchor="ctr"/>
+          <a:lstStyle/>
           <a:p>
             <a:pPr indent="0" marL="0">
               <a:buNone/>
             </a:pPr>
             <a:r>
-              <a:rPr lang="en-US" sz="1500" dirty="0">
-                <a:solidFill>
-                  <a:schemeClr val="accent6"/>
+              <a:rPr lang="en-US" sz="1100" dirty="0">
+                <a:solidFill>
+                  <a:schemeClr val="accent5"/>
                 </a:solidFill>
               </a:rPr>
-              <a:t>Traceability, stock accuracy and operator usability</a:t>
+              <a:t>No licences: hosting, support time, one-time hardening and security review</a:t>
             </a:r>
-            <a:endParaRPr lang="en-US" sz="2200" dirty="0"/>
-          </a:p>
-        </p:txBody>
-      </p:sp>
-      <p:pic>
-        <p:nvPicPr>
-          <p:cNvPr id="13" name="Image 0" descr="MachineCare on a phone-sized screen">    </p:cNvPr>
-          <p:cNvPicPr>
-            <a:picLocks noChangeAspect="1"/>
-          </p:cNvPicPr>
-          <p:nvPr/>
-        </p:nvPicPr>
-        <p:blipFill>
-          <a:blip r:embed="rId1"/>
-          <a:stretch>
-            <a:fillRect/>
-          </a:stretch>
-        </p:blipFill>
-        <p:spPr>
-          <a:xfrm>
-            <a:off x="9326880" y="1280160"/>
-            <a:ext cx="1737360" cy="3636335"/>
-          </a:xfrm>
-          <a:prstGeom prst="rect">
-            <a:avLst/>
-          </a:prstGeom>
-        </p:spPr>
-      </p:pic>
+            <a:endParaRPr lang="en-US" sz="1100" dirty="0"/>
+          </a:p>
+        </p:txBody>
+      </p:sp>
+      <p:sp>
+        <p:nvSpPr>
+          <p:cNvPr id="13" name="Shape 10"/>
+          <p:cNvSpPr/>
+          <p:nvPr/>
+        </p:nvSpPr>
+        <p:spPr>
+          <a:xfrm>
+            <a:off x="7772400" y="4581144"/>
+            <a:ext cx="3840480" cy="1371600"/>
+          </a:xfrm>
+          <a:prstGeom prst="roundRect">
+            <a:avLst>
+              <a:gd name="adj" fmla="val 6667"/>
+            </a:avLst>
+          </a:prstGeom>
+          <a:solidFill>
+            <a:schemeClr val="bg1"/>
+          </a:solidFill>
+          <a:ln w="9525">
+            <a:solidFill>
+              <a:srgbClr val="D5E0E3"/>
+            </a:solidFill>
+            <a:prstDash val="solid"/>
+          </a:ln>
+          <a:effectLst>
+            <a:outerShdw sx="100000" sy="100000" kx="0" ky="0" algn="bl" rotWithShape="0" blurRad="101600" dist="25400" dir="5400000">
+              <a:srgbClr val="0F2A3A">
+                <a:alpha val="18000"/>
+              </a:srgbClr>
+            </a:outerShdw>
+          </a:effectLst>
+        </p:spPr>
+      </p:sp>
       <p:sp>
         <p:nvSpPr>
           <p:cNvPr id="14" name="Text 11"/>
@@ -12337,44 +12902,8 @@
         </p:nvSpPr>
         <p:spPr>
           <a:xfrm>
-            <a:off x="9052560" y="5029200"/>
-            <a:ext cx="2286000" cy="365760"/>
-          </a:xfrm>
-          <a:prstGeom prst="rect">
-            <a:avLst/>
-          </a:prstGeom>
-          <a:noFill/>
-          <a:ln/>
-        </p:spPr>
-        <p:txBody>
-          <a:bodyPr wrap="square" lIns="0" tIns="0" rIns="0" bIns="0" rtlCol="0" anchor="ctr"/>
-          <a:lstStyle/>
-          <a:p>
-            <a:pPr algn="ctr" indent="0" marL="0">
-              <a:buNone/>
-            </a:pPr>
-            <a:r>
-              <a:rPr lang="en-US" sz="1200" dirty="0">
-                <a:solidFill>
-                  <a:schemeClr val="accent6"/>
-                </a:solidFill>
-              </a:rPr>
-              <a:t>Also works on a phone</a:t>
-            </a:r>
-            <a:endParaRPr lang="en-US" sz="1200" dirty="0"/>
-          </a:p>
-        </p:txBody>
-      </p:sp>
-      <p:sp>
-        <p:nvSpPr>
-          <p:cNvPr id="15" name="Text 12"/>
-          <p:cNvSpPr txBox="1"/>
-          <p:nvPr/>
-        </p:nvSpPr>
-        <p:spPr>
-          <a:xfrm>
-            <a:off x="548640" y="5852160"/>
-            <a:ext cx="8229600" cy="457200"/>
+            <a:off x="8001000" y="4690872"/>
+            <a:ext cx="3474720" cy="274320"/>
           </a:xfrm>
           <a:prstGeom prst="rect">
             <a:avLst/>
@@ -12390,14 +12919,122 @@
               <a:buNone/>
             </a:pPr>
             <a:r>
-              <a:rPr lang="en-US" sz="1600" i="1" dirty="0">
-                <a:solidFill>
-                  <a:schemeClr val="accent2"/>
+              <a:rPr lang="en-US" sz="1300" b="1" dirty="0">
+                <a:solidFill>
+                  <a:schemeClr val="accent5"/>
                 </a:solidFill>
               </a:rPr>
-              <a:t>A working local pilot today. A controlled release after validation.</a:t>
+              <a:t>Saving over 5 years</a:t>
             </a:r>
-            <a:endParaRPr lang="en-US" sz="1600" dirty="0"/>
+            <a:endParaRPr lang="en-US" sz="1300" dirty="0"/>
+          </a:p>
+        </p:txBody>
+      </p:sp>
+      <p:sp>
+        <p:nvSpPr>
+          <p:cNvPr id="15" name="Text 12"/>
+          <p:cNvSpPr txBox="1"/>
+          <p:nvPr/>
+        </p:nvSpPr>
+        <p:spPr>
+          <a:xfrm>
+            <a:off x="8001000" y="4965192"/>
+            <a:ext cx="3474720" cy="502920"/>
+          </a:xfrm>
+          <a:prstGeom prst="rect">
+            <a:avLst/>
+          </a:prstGeom>
+          <a:noFill/>
+          <a:ln/>
+        </p:spPr>
+        <p:txBody>
+          <a:bodyPr wrap="square" lIns="0" tIns="0" rIns="0" bIns="0" rtlCol="0" anchor="ctr"/>
+          <a:lstStyle/>
+          <a:p>
+            <a:pPr indent="0" marL="0">
+              <a:buNone/>
+            </a:pPr>
+            <a:r>
+              <a:rPr lang="en-US" sz="2800" b="1" dirty="0">
+                <a:solidFill>
+                  <a:schemeClr val="tx2"/>
+                </a:solidFill>
+              </a:rPr>
+              <a:t>$134,000</a:t>
+            </a:r>
+            <a:endParaRPr lang="en-US" sz="2800" dirty="0"/>
+          </a:p>
+        </p:txBody>
+      </p:sp>
+      <p:sp>
+        <p:nvSpPr>
+          <p:cNvPr id="16" name="Text 13"/>
+          <p:cNvSpPr txBox="1"/>
+          <p:nvPr/>
+        </p:nvSpPr>
+        <p:spPr>
+          <a:xfrm>
+            <a:off x="8001000" y="5468112"/>
+            <a:ext cx="3474720" cy="411480"/>
+          </a:xfrm>
+          <a:prstGeom prst="rect">
+            <a:avLst/>
+          </a:prstGeom>
+          <a:noFill/>
+          <a:ln/>
+        </p:spPr>
+        <p:txBody>
+          <a:bodyPr wrap="square" lIns="0" tIns="0" rIns="0" bIns="0" rtlCol="0" anchor="ctr"/>
+          <a:lstStyle/>
+          <a:p>
+            <a:pPr indent="0" marL="0">
+              <a:buNone/>
+            </a:pPr>
+            <a:r>
+              <a:rPr lang="en-US" sz="1100" dirty="0">
+                <a:solidFill>
+                  <a:schemeClr val="accent5"/>
+                </a:solidFill>
+              </a:rPr>
+              <a:t>Running cost ≈ $13 vs $50 per user per month</a:t>
+            </a:r>
+            <a:endParaRPr lang="en-US" sz="1100" dirty="0"/>
+          </a:p>
+        </p:txBody>
+      </p:sp>
+      <p:sp>
+        <p:nvSpPr>
+          <p:cNvPr id="17" name="Text 14"/>
+          <p:cNvSpPr txBox="1"/>
+          <p:nvPr/>
+        </p:nvSpPr>
+        <p:spPr>
+          <a:xfrm>
+            <a:off x="548640" y="6108192"/>
+            <a:ext cx="11064240" cy="274320"/>
+          </a:xfrm>
+          <a:prstGeom prst="rect">
+            <a:avLst/>
+          </a:prstGeom>
+          <a:noFill/>
+          <a:ln/>
+        </p:spPr>
+        <p:txBody>
+          <a:bodyPr wrap="square" lIns="0" tIns="0" rIns="0" bIns="0" rtlCol="0" anchor="ctr"/>
+          <a:lstStyle/>
+          <a:p>
+            <a:pPr indent="0" marL="0">
+              <a:buNone/>
+            </a:pPr>
+            <a:r>
+              <a:rPr lang="en-US" sz="1000" i="1" dirty="0">
+                <a:solidFill>
+                  <a:schemeClr val="accent5"/>
+                </a:solidFill>
+              </a:rPr>
+              <a:t>Vendor figures: the quote received. MachineCare figures: planning assumptions (next slide), editable in docs/budget/MachineCare_Cost_Comparison.xlsx.</a:t>
+            </a:r>
+            <a:endParaRPr lang="en-US" sz="1000" dirty="0"/>
           </a:p>
         </p:txBody>
       </p:sp>
@@ -12431,7 +13068,7 @@
             <a:lvl1pPr>
               <a:defRPr sz="1000">
                 <a:solidFill>
-                  <a:schemeClr val="accent2"/>
+                  <a:schemeClr val="accent5"/>
                 </a:solidFill>
               </a:defRPr>
             </a:lvl1pPr>
@@ -13168,7 +13805,7 @@
                   <a:schemeClr val="accent1"/>
                 </a:solidFill>
               </a:rPr>
-              <a:t>APPENDIX A</a:t>
+              <a:t>BUDGET · WHAT MACHINECARE NEEDS</a:t>
             </a:r>
             <a:endParaRPr lang="en-US" sz="1200" dirty="0"/>
           </a:p>
@@ -13206,6 +13843,3150 @@
                   <a:schemeClr val="tx2"/>
                 </a:solidFill>
               </a:rPr>
+              <a:t>Budget plan to run MachineCare here</a:t>
+            </a:r>
+            <a:endParaRPr lang="en-US" sz="3200" dirty="0"/>
+          </a:p>
+        </p:txBody>
+      </p:sp>
+      <p:graphicFrame>
+        <p:nvGraphicFramePr>
+          <p:cNvPr id="21" name="Table 0"/>
+          <p:cNvGraphicFramePr>
+            <a:graphicFrameLocks noGrp="1"/>
+          </p:cNvGraphicFramePr>
+          <p:nvPr>
+            <p:extLst>
+              <p:ext uri="{D42A27DB-BD31-4B8C-83A1-F6EECF244321}">
+                <p14:modId xmlns:p14="http://schemas.microsoft.com/office/powerpoint/2010/main" val="1579011935"/>
+              </p:ext>
+            </p:extLst>
+          </p:nvPr>
+        </p:nvGraphicFramePr>
+        <p:xfrm>
+          <a:off x="548640" y="1508760"/>
+          <a:ext cx="7406640" cy="914400"/>
+        </p:xfrm>
+        <a:graphic>
+          <a:graphicData uri="http://schemas.openxmlformats.org/drawingml/2006/table">
+            <a:tbl>
+              <a:tblPr/>
+              <a:tblGrid>
+                <a:gridCol w="2651760"/>
+                <a:gridCol w="2651760"/>
+                <a:gridCol w="1051560"/>
+                <a:gridCol w="1051560"/>
+              </a:tblGrid>
+              <a:tr h="457200">
+                <a:tc>
+                  <a:txBody>
+                    <a:bodyPr/>
+                    <a:lstStyle/>
+                    <a:p>
+                      <a:pPr algn="l" indent="0" marL="0">
+                        <a:buNone/>
+                      </a:pPr>
+                      <a:r>
+                        <a:rPr lang="en-US" sz="1300" b="1" dirty="0">
+                          <a:solidFill>
+                            <a:srgbClr val="FFFFFF"/>
+                          </a:solidFill>
+                        </a:rPr>
+                        <a:t>Item</a:t>
+                      </a:r>
+                      <a:endParaRPr lang="en-US" sz="1300" dirty="0"/>
+                    </a:p>
+                  </a:txBody>
+                  <a:tcPr marL="73152" marR="73152" marT="27432" marB="27432" anchor="ctr">
+                    <a:lnL w="9525" cap="flat" cmpd="sng" algn="ctr">
+                      <a:solidFill>
+                        <a:srgbClr val="D5E0E3"/>
+                      </a:solidFill>
+                      <a:prstDash val="solid"/>
+                      <a:round/>
+                      <a:headEnd type="none" w="med" len="med"/>
+                      <a:tailEnd type="none" w="med" len="med"/>
+                    </a:lnL>
+                    <a:lnR w="9525" cap="flat" cmpd="sng" algn="ctr">
+                      <a:solidFill>
+                        <a:srgbClr val="D5E0E3"/>
+                      </a:solidFill>
+                      <a:prstDash val="solid"/>
+                      <a:round/>
+                      <a:headEnd type="none" w="med" len="med"/>
+                      <a:tailEnd type="none" w="med" len="med"/>
+                    </a:lnR>
+                    <a:lnT w="9525" cap="flat" cmpd="sng" algn="ctr">
+                      <a:solidFill>
+                        <a:srgbClr val="D5E0E3"/>
+                      </a:solidFill>
+                      <a:prstDash val="solid"/>
+                      <a:round/>
+                      <a:headEnd type="none" w="med" len="med"/>
+                      <a:tailEnd type="none" w="med" len="med"/>
+                    </a:lnT>
+                    <a:lnB w="9525" cap="flat" cmpd="sng" algn="ctr">
+                      <a:solidFill>
+                        <a:srgbClr val="D5E0E3"/>
+                      </a:solidFill>
+                      <a:prstDash val="solid"/>
+                      <a:round/>
+                      <a:headEnd type="none" w="med" len="med"/>
+                      <a:tailEnd type="none" w="med" len="med"/>
+                    </a:lnB>
+                    <a:solidFill>
+                      <a:srgbClr val="0F2A3A"/>
+                    </a:solidFill>
+                  </a:tcPr>
+                </a:tc>
+                <a:tc>
+                  <a:txBody>
+                    <a:bodyPr/>
+                    <a:lstStyle/>
+                    <a:p>
+                      <a:pPr algn="l" indent="0" marL="0">
+                        <a:buNone/>
+                      </a:pPr>
+                      <a:r>
+                        <a:rPr lang="en-US" sz="1300" b="1" dirty="0">
+                          <a:solidFill>
+                            <a:srgbClr val="FFFFFF"/>
+                          </a:solidFill>
+                        </a:rPr>
+                        <a:t>Basis (assumption)</a:t>
+                      </a:r>
+                      <a:endParaRPr lang="en-US" sz="1300" dirty="0"/>
+                    </a:p>
+                  </a:txBody>
+                  <a:tcPr marL="73152" marR="73152" marT="27432" marB="27432" anchor="ctr">
+                    <a:lnL w="9525" cap="flat" cmpd="sng" algn="ctr">
+                      <a:solidFill>
+                        <a:srgbClr val="D5E0E3"/>
+                      </a:solidFill>
+                      <a:prstDash val="solid"/>
+                      <a:round/>
+                      <a:headEnd type="none" w="med" len="med"/>
+                      <a:tailEnd type="none" w="med" len="med"/>
+                    </a:lnL>
+                    <a:lnR w="9525" cap="flat" cmpd="sng" algn="ctr">
+                      <a:solidFill>
+                        <a:srgbClr val="D5E0E3"/>
+                      </a:solidFill>
+                      <a:prstDash val="solid"/>
+                      <a:round/>
+                      <a:headEnd type="none" w="med" len="med"/>
+                      <a:tailEnd type="none" w="med" len="med"/>
+                    </a:lnR>
+                    <a:lnT w="9525" cap="flat" cmpd="sng" algn="ctr">
+                      <a:solidFill>
+                        <a:srgbClr val="D5E0E3"/>
+                      </a:solidFill>
+                      <a:prstDash val="solid"/>
+                      <a:round/>
+                      <a:headEnd type="none" w="med" len="med"/>
+                      <a:tailEnd type="none" w="med" len="med"/>
+                    </a:lnT>
+                    <a:lnB w="9525" cap="flat" cmpd="sng" algn="ctr">
+                      <a:solidFill>
+                        <a:srgbClr val="D5E0E3"/>
+                      </a:solidFill>
+                      <a:prstDash val="solid"/>
+                      <a:round/>
+                      <a:headEnd type="none" w="med" len="med"/>
+                      <a:tailEnd type="none" w="med" len="med"/>
+                    </a:lnB>
+                    <a:solidFill>
+                      <a:srgbClr val="0F2A3A"/>
+                    </a:solidFill>
+                  </a:tcPr>
+                </a:tc>
+                <a:tc>
+                  <a:txBody>
+                    <a:bodyPr/>
+                    <a:lstStyle/>
+                    <a:p>
+                      <a:pPr algn="r" indent="0" marL="0">
+                        <a:buNone/>
+                      </a:pPr>
+                      <a:r>
+                        <a:rPr lang="en-US" sz="1300" b="1" dirty="0">
+                          <a:solidFill>
+                            <a:srgbClr val="FFFFFF"/>
+                          </a:solidFill>
+                        </a:rPr>
+                        <a:t>Year 1</a:t>
+                      </a:r>
+                      <a:endParaRPr lang="en-US" sz="1300" dirty="0"/>
+                    </a:p>
+                  </a:txBody>
+                  <a:tcPr marL="73152" marR="73152" marT="27432" marB="27432" anchor="ctr">
+                    <a:lnL w="9525" cap="flat" cmpd="sng" algn="ctr">
+                      <a:solidFill>
+                        <a:srgbClr val="D5E0E3"/>
+                      </a:solidFill>
+                      <a:prstDash val="solid"/>
+                      <a:round/>
+                      <a:headEnd type="none" w="med" len="med"/>
+                      <a:tailEnd type="none" w="med" len="med"/>
+                    </a:lnL>
+                    <a:lnR w="9525" cap="flat" cmpd="sng" algn="ctr">
+                      <a:solidFill>
+                        <a:srgbClr val="D5E0E3"/>
+                      </a:solidFill>
+                      <a:prstDash val="solid"/>
+                      <a:round/>
+                      <a:headEnd type="none" w="med" len="med"/>
+                      <a:tailEnd type="none" w="med" len="med"/>
+                    </a:lnR>
+                    <a:lnT w="9525" cap="flat" cmpd="sng" algn="ctr">
+                      <a:solidFill>
+                        <a:srgbClr val="D5E0E3"/>
+                      </a:solidFill>
+                      <a:prstDash val="solid"/>
+                      <a:round/>
+                      <a:headEnd type="none" w="med" len="med"/>
+                      <a:tailEnd type="none" w="med" len="med"/>
+                    </a:lnT>
+                    <a:lnB w="9525" cap="flat" cmpd="sng" algn="ctr">
+                      <a:solidFill>
+                        <a:srgbClr val="D5E0E3"/>
+                      </a:solidFill>
+                      <a:prstDash val="solid"/>
+                      <a:round/>
+                      <a:headEnd type="none" w="med" len="med"/>
+                      <a:tailEnd type="none" w="med" len="med"/>
+                    </a:lnB>
+                    <a:solidFill>
+                      <a:srgbClr val="0F2A3A"/>
+                    </a:solidFill>
+                  </a:tcPr>
+                </a:tc>
+                <a:tc>
+                  <a:txBody>
+                    <a:bodyPr/>
+                    <a:lstStyle/>
+                    <a:p>
+                      <a:pPr algn="r" indent="0" marL="0">
+                        <a:buNone/>
+                      </a:pPr>
+                      <a:r>
+                        <a:rPr lang="en-US" sz="1300" b="1" dirty="0">
+                          <a:solidFill>
+                            <a:srgbClr val="FFFFFF"/>
+                          </a:solidFill>
+                        </a:rPr>
+                        <a:t>Each later year</a:t>
+                      </a:r>
+                      <a:endParaRPr lang="en-US" sz="1300" dirty="0"/>
+                    </a:p>
+                  </a:txBody>
+                  <a:tcPr marL="73152" marR="73152" marT="27432" marB="27432" anchor="ctr">
+                    <a:lnL w="9525" cap="flat" cmpd="sng" algn="ctr">
+                      <a:solidFill>
+                        <a:srgbClr val="D5E0E3"/>
+                      </a:solidFill>
+                      <a:prstDash val="solid"/>
+                      <a:round/>
+                      <a:headEnd type="none" w="med" len="med"/>
+                      <a:tailEnd type="none" w="med" len="med"/>
+                    </a:lnL>
+                    <a:lnR w="9525" cap="flat" cmpd="sng" algn="ctr">
+                      <a:solidFill>
+                        <a:srgbClr val="D5E0E3"/>
+                      </a:solidFill>
+                      <a:prstDash val="solid"/>
+                      <a:round/>
+                      <a:headEnd type="none" w="med" len="med"/>
+                      <a:tailEnd type="none" w="med" len="med"/>
+                    </a:lnR>
+                    <a:lnT w="9525" cap="flat" cmpd="sng" algn="ctr">
+                      <a:solidFill>
+                        <a:srgbClr val="D5E0E3"/>
+                      </a:solidFill>
+                      <a:prstDash val="solid"/>
+                      <a:round/>
+                      <a:headEnd type="none" w="med" len="med"/>
+                      <a:tailEnd type="none" w="med" len="med"/>
+                    </a:lnT>
+                    <a:lnB w="9525" cap="flat" cmpd="sng" algn="ctr">
+                      <a:solidFill>
+                        <a:srgbClr val="D5E0E3"/>
+                      </a:solidFill>
+                      <a:prstDash val="solid"/>
+                      <a:round/>
+                      <a:headEnd type="none" w="med" len="med"/>
+                      <a:tailEnd type="none" w="med" len="med"/>
+                    </a:lnB>
+                    <a:solidFill>
+                      <a:srgbClr val="0F2A3A"/>
+                    </a:solidFill>
+                  </a:tcPr>
+                </a:tc>
+              </a:tr>
+              <a:tr h="457200">
+                <a:tc>
+                  <a:txBody>
+                    <a:bodyPr/>
+                    <a:lstStyle/>
+                    <a:p>
+                      <a:pPr algn="l" indent="0" marL="0">
+                        <a:buNone/>
+                      </a:pPr>
+                      <a:r>
+                        <a:rPr lang="en-US" sz="1300" b="1" dirty="0">
+                          <a:solidFill>
+                            <a:srgbClr val="17232E"/>
+                          </a:solidFill>
+                        </a:rPr>
+                        <a:t>Production hardening &amp; deployment</a:t>
+                      </a:r>
+                      <a:endParaRPr lang="en-US" sz="1300" dirty="0"/>
+                    </a:p>
+                  </a:txBody>
+                  <a:tcPr marL="73152" marR="73152" marT="27432" marB="27432" anchor="ctr">
+                    <a:lnL w="9525" cap="flat" cmpd="sng" algn="ctr">
+                      <a:solidFill>
+                        <a:srgbClr val="D5E0E3"/>
+                      </a:solidFill>
+                      <a:prstDash val="solid"/>
+                      <a:round/>
+                      <a:headEnd type="none" w="med" len="med"/>
+                      <a:tailEnd type="none" w="med" len="med"/>
+                    </a:lnL>
+                    <a:lnR w="9525" cap="flat" cmpd="sng" algn="ctr">
+                      <a:solidFill>
+                        <a:srgbClr val="D5E0E3"/>
+                      </a:solidFill>
+                      <a:prstDash val="solid"/>
+                      <a:round/>
+                      <a:headEnd type="none" w="med" len="med"/>
+                      <a:tailEnd type="none" w="med" len="med"/>
+                    </a:lnR>
+                    <a:lnT w="9525" cap="flat" cmpd="sng" algn="ctr">
+                      <a:solidFill>
+                        <a:srgbClr val="D5E0E3"/>
+                      </a:solidFill>
+                      <a:prstDash val="solid"/>
+                      <a:round/>
+                      <a:headEnd type="none" w="med" len="med"/>
+                      <a:tailEnd type="none" w="med" len="med"/>
+                    </a:lnT>
+                    <a:lnB w="9525" cap="flat" cmpd="sng" algn="ctr">
+                      <a:solidFill>
+                        <a:srgbClr val="D5E0E3"/>
+                      </a:solidFill>
+                      <a:prstDash val="solid"/>
+                      <a:round/>
+                      <a:headEnd type="none" w="med" len="med"/>
+                      <a:tailEnd type="none" w="med" len="med"/>
+                    </a:lnB>
+                    <a:solidFill>
+                      <a:srgbClr val="FFFFFF"/>
+                    </a:solidFill>
+                  </a:tcPr>
+                </a:tc>
+                <a:tc>
+                  <a:txBody>
+                    <a:bodyPr/>
+                    <a:lstStyle/>
+                    <a:p>
+                      <a:pPr algn="l" indent="0" marL="0">
+                        <a:buNone/>
+                      </a:pPr>
+                      <a:r>
+                        <a:rPr lang="en-US" sz="1300" dirty="0">
+                          <a:solidFill>
+                            <a:srgbClr val="17232E"/>
+                          </a:solidFill>
+                        </a:rPr>
+                        <a:t>160 h × $40/h</a:t>
+                      </a:r>
+                      <a:endParaRPr lang="en-US" sz="1300" dirty="0"/>
+                    </a:p>
+                  </a:txBody>
+                  <a:tcPr marL="73152" marR="73152" marT="27432" marB="27432" anchor="ctr">
+                    <a:lnL w="9525" cap="flat" cmpd="sng" algn="ctr">
+                      <a:solidFill>
+                        <a:srgbClr val="D5E0E3"/>
+                      </a:solidFill>
+                      <a:prstDash val="solid"/>
+                      <a:round/>
+                      <a:headEnd type="none" w="med" len="med"/>
+                      <a:tailEnd type="none" w="med" len="med"/>
+                    </a:lnL>
+                    <a:lnR w="9525" cap="flat" cmpd="sng" algn="ctr">
+                      <a:solidFill>
+                        <a:srgbClr val="D5E0E3"/>
+                      </a:solidFill>
+                      <a:prstDash val="solid"/>
+                      <a:round/>
+                      <a:headEnd type="none" w="med" len="med"/>
+                      <a:tailEnd type="none" w="med" len="med"/>
+                    </a:lnR>
+                    <a:lnT w="9525" cap="flat" cmpd="sng" algn="ctr">
+                      <a:solidFill>
+                        <a:srgbClr val="D5E0E3"/>
+                      </a:solidFill>
+                      <a:prstDash val="solid"/>
+                      <a:round/>
+                      <a:headEnd type="none" w="med" len="med"/>
+                      <a:tailEnd type="none" w="med" len="med"/>
+                    </a:lnT>
+                    <a:lnB w="9525" cap="flat" cmpd="sng" algn="ctr">
+                      <a:solidFill>
+                        <a:srgbClr val="D5E0E3"/>
+                      </a:solidFill>
+                      <a:prstDash val="solid"/>
+                      <a:round/>
+                      <a:headEnd type="none" w="med" len="med"/>
+                      <a:tailEnd type="none" w="med" len="med"/>
+                    </a:lnB>
+                    <a:solidFill>
+                      <a:srgbClr val="FFFFFF"/>
+                    </a:solidFill>
+                  </a:tcPr>
+                </a:tc>
+                <a:tc>
+                  <a:txBody>
+                    <a:bodyPr/>
+                    <a:lstStyle/>
+                    <a:p>
+                      <a:pPr algn="r" indent="0" marL="0">
+                        <a:buNone/>
+                      </a:pPr>
+                      <a:r>
+                        <a:rPr lang="en-US" sz="1300" dirty="0">
+                          <a:solidFill>
+                            <a:srgbClr val="17232E"/>
+                          </a:solidFill>
+                        </a:rPr>
+                        <a:t>$6,400</a:t>
+                      </a:r>
+                      <a:endParaRPr lang="en-US" sz="1300" dirty="0"/>
+                    </a:p>
+                  </a:txBody>
+                  <a:tcPr marL="73152" marR="73152" marT="27432" marB="27432" anchor="ctr">
+                    <a:lnL w="9525" cap="flat" cmpd="sng" algn="ctr">
+                      <a:solidFill>
+                        <a:srgbClr val="D5E0E3"/>
+                      </a:solidFill>
+                      <a:prstDash val="solid"/>
+                      <a:round/>
+                      <a:headEnd type="none" w="med" len="med"/>
+                      <a:tailEnd type="none" w="med" len="med"/>
+                    </a:lnL>
+                    <a:lnR w="9525" cap="flat" cmpd="sng" algn="ctr">
+                      <a:solidFill>
+                        <a:srgbClr val="D5E0E3"/>
+                      </a:solidFill>
+                      <a:prstDash val="solid"/>
+                      <a:round/>
+                      <a:headEnd type="none" w="med" len="med"/>
+                      <a:tailEnd type="none" w="med" len="med"/>
+                    </a:lnR>
+                    <a:lnT w="9525" cap="flat" cmpd="sng" algn="ctr">
+                      <a:solidFill>
+                        <a:srgbClr val="D5E0E3"/>
+                      </a:solidFill>
+                      <a:prstDash val="solid"/>
+                      <a:round/>
+                      <a:headEnd type="none" w="med" len="med"/>
+                      <a:tailEnd type="none" w="med" len="med"/>
+                    </a:lnT>
+                    <a:lnB w="9525" cap="flat" cmpd="sng" algn="ctr">
+                      <a:solidFill>
+                        <a:srgbClr val="D5E0E3"/>
+                      </a:solidFill>
+                      <a:prstDash val="solid"/>
+                      <a:round/>
+                      <a:headEnd type="none" w="med" len="med"/>
+                      <a:tailEnd type="none" w="med" len="med"/>
+                    </a:lnB>
+                    <a:solidFill>
+                      <a:srgbClr val="FFFFFF"/>
+                    </a:solidFill>
+                  </a:tcPr>
+                </a:tc>
+                <a:tc>
+                  <a:txBody>
+                    <a:bodyPr/>
+                    <a:lstStyle/>
+                    <a:p>
+                      <a:pPr algn="r" indent="0" marL="0">
+                        <a:buNone/>
+                      </a:pPr>
+                      <a:r>
+                        <a:rPr lang="en-US" sz="1300" dirty="0">
+                          <a:solidFill>
+                            <a:srgbClr val="17232E"/>
+                          </a:solidFill>
+                        </a:rPr>
+                        <a:t>—</a:t>
+                      </a:r>
+                      <a:endParaRPr lang="en-US" sz="1300" dirty="0"/>
+                    </a:p>
+                  </a:txBody>
+                  <a:tcPr marL="73152" marR="73152" marT="27432" marB="27432" anchor="ctr">
+                    <a:lnL w="9525" cap="flat" cmpd="sng" algn="ctr">
+                      <a:solidFill>
+                        <a:srgbClr val="D5E0E3"/>
+                      </a:solidFill>
+                      <a:prstDash val="solid"/>
+                      <a:round/>
+                      <a:headEnd type="none" w="med" len="med"/>
+                      <a:tailEnd type="none" w="med" len="med"/>
+                    </a:lnL>
+                    <a:lnR w="9525" cap="flat" cmpd="sng" algn="ctr">
+                      <a:solidFill>
+                        <a:srgbClr val="D5E0E3"/>
+                      </a:solidFill>
+                      <a:prstDash val="solid"/>
+                      <a:round/>
+                      <a:headEnd type="none" w="med" len="med"/>
+                      <a:tailEnd type="none" w="med" len="med"/>
+                    </a:lnR>
+                    <a:lnT w="9525" cap="flat" cmpd="sng" algn="ctr">
+                      <a:solidFill>
+                        <a:srgbClr val="D5E0E3"/>
+                      </a:solidFill>
+                      <a:prstDash val="solid"/>
+                      <a:round/>
+                      <a:headEnd type="none" w="med" len="med"/>
+                      <a:tailEnd type="none" w="med" len="med"/>
+                    </a:lnT>
+                    <a:lnB w="9525" cap="flat" cmpd="sng" algn="ctr">
+                      <a:solidFill>
+                        <a:srgbClr val="D5E0E3"/>
+                      </a:solidFill>
+                      <a:prstDash val="solid"/>
+                      <a:round/>
+                      <a:headEnd type="none" w="med" len="med"/>
+                      <a:tailEnd type="none" w="med" len="med"/>
+                    </a:lnB>
+                    <a:solidFill>
+                      <a:srgbClr val="FFFFFF"/>
+                    </a:solidFill>
+                  </a:tcPr>
+                </a:tc>
+              </a:tr>
+              <a:tr h="457200">
+                <a:tc>
+                  <a:txBody>
+                    <a:bodyPr/>
+                    <a:lstStyle/>
+                    <a:p>
+                      <a:pPr algn="l" indent="0" marL="0">
+                        <a:buNone/>
+                      </a:pPr>
+                      <a:r>
+                        <a:rPr lang="en-US" sz="1300" b="1" dirty="0">
+                          <a:solidFill>
+                            <a:srgbClr val="17232E"/>
+                          </a:solidFill>
+                        </a:rPr>
+                        <a:t>Independent security review</a:t>
+                      </a:r>
+                      <a:endParaRPr lang="en-US" sz="1300" dirty="0"/>
+                    </a:p>
+                  </a:txBody>
+                  <a:tcPr marL="73152" marR="73152" marT="27432" marB="27432" anchor="ctr">
+                    <a:lnL w="9525" cap="flat" cmpd="sng" algn="ctr">
+                      <a:solidFill>
+                        <a:srgbClr val="D5E0E3"/>
+                      </a:solidFill>
+                      <a:prstDash val="solid"/>
+                      <a:round/>
+                      <a:headEnd type="none" w="med" len="med"/>
+                      <a:tailEnd type="none" w="med" len="med"/>
+                    </a:lnL>
+                    <a:lnR w="9525" cap="flat" cmpd="sng" algn="ctr">
+                      <a:solidFill>
+                        <a:srgbClr val="D5E0E3"/>
+                      </a:solidFill>
+                      <a:prstDash val="solid"/>
+                      <a:round/>
+                      <a:headEnd type="none" w="med" len="med"/>
+                      <a:tailEnd type="none" w="med" len="med"/>
+                    </a:lnR>
+                    <a:lnT w="9525" cap="flat" cmpd="sng" algn="ctr">
+                      <a:solidFill>
+                        <a:srgbClr val="D5E0E3"/>
+                      </a:solidFill>
+                      <a:prstDash val="solid"/>
+                      <a:round/>
+                      <a:headEnd type="none" w="med" len="med"/>
+                      <a:tailEnd type="none" w="med" len="med"/>
+                    </a:lnT>
+                    <a:lnB w="9525" cap="flat" cmpd="sng" algn="ctr">
+                      <a:solidFill>
+                        <a:srgbClr val="D5E0E3"/>
+                      </a:solidFill>
+                      <a:prstDash val="solid"/>
+                      <a:round/>
+                      <a:headEnd type="none" w="med" len="med"/>
+                      <a:tailEnd type="none" w="med" len="med"/>
+                    </a:lnB>
+                    <a:solidFill>
+                      <a:srgbClr val="F5F9FA"/>
+                    </a:solidFill>
+                  </a:tcPr>
+                </a:tc>
+                <a:tc>
+                  <a:txBody>
+                    <a:bodyPr/>
+                    <a:lstStyle/>
+                    <a:p>
+                      <a:pPr algn="l" indent="0" marL="0">
+                        <a:buNone/>
+                      </a:pPr>
+                      <a:r>
+                        <a:rPr lang="en-US" sz="1300" dirty="0">
+                          <a:solidFill>
+                            <a:srgbClr val="17232E"/>
+                          </a:solidFill>
+                        </a:rPr>
+                        <a:t>External quote needed</a:t>
+                      </a:r>
+                      <a:endParaRPr lang="en-US" sz="1300" dirty="0"/>
+                    </a:p>
+                  </a:txBody>
+                  <a:tcPr marL="73152" marR="73152" marT="27432" marB="27432" anchor="ctr">
+                    <a:lnL w="9525" cap="flat" cmpd="sng" algn="ctr">
+                      <a:solidFill>
+                        <a:srgbClr val="D5E0E3"/>
+                      </a:solidFill>
+                      <a:prstDash val="solid"/>
+                      <a:round/>
+                      <a:headEnd type="none" w="med" len="med"/>
+                      <a:tailEnd type="none" w="med" len="med"/>
+                    </a:lnL>
+                    <a:lnR w="9525" cap="flat" cmpd="sng" algn="ctr">
+                      <a:solidFill>
+                        <a:srgbClr val="D5E0E3"/>
+                      </a:solidFill>
+                      <a:prstDash val="solid"/>
+                      <a:round/>
+                      <a:headEnd type="none" w="med" len="med"/>
+                      <a:tailEnd type="none" w="med" len="med"/>
+                    </a:lnR>
+                    <a:lnT w="9525" cap="flat" cmpd="sng" algn="ctr">
+                      <a:solidFill>
+                        <a:srgbClr val="D5E0E3"/>
+                      </a:solidFill>
+                      <a:prstDash val="solid"/>
+                      <a:round/>
+                      <a:headEnd type="none" w="med" len="med"/>
+                      <a:tailEnd type="none" w="med" len="med"/>
+                    </a:lnT>
+                    <a:lnB w="9525" cap="flat" cmpd="sng" algn="ctr">
+                      <a:solidFill>
+                        <a:srgbClr val="D5E0E3"/>
+                      </a:solidFill>
+                      <a:prstDash val="solid"/>
+                      <a:round/>
+                      <a:headEnd type="none" w="med" len="med"/>
+                      <a:tailEnd type="none" w="med" len="med"/>
+                    </a:lnB>
+                    <a:solidFill>
+                      <a:srgbClr val="F5F9FA"/>
+                    </a:solidFill>
+                  </a:tcPr>
+                </a:tc>
+                <a:tc>
+                  <a:txBody>
+                    <a:bodyPr/>
+                    <a:lstStyle/>
+                    <a:p>
+                      <a:pPr algn="r" indent="0" marL="0">
+                        <a:buNone/>
+                      </a:pPr>
+                      <a:r>
+                        <a:rPr lang="en-US" sz="1300" dirty="0">
+                          <a:solidFill>
+                            <a:srgbClr val="17232E"/>
+                          </a:solidFill>
+                        </a:rPr>
+                        <a:t>$8,000</a:t>
+                      </a:r>
+                      <a:endParaRPr lang="en-US" sz="1300" dirty="0"/>
+                    </a:p>
+                  </a:txBody>
+                  <a:tcPr marL="73152" marR="73152" marT="27432" marB="27432" anchor="ctr">
+                    <a:lnL w="9525" cap="flat" cmpd="sng" algn="ctr">
+                      <a:solidFill>
+                        <a:srgbClr val="D5E0E3"/>
+                      </a:solidFill>
+                      <a:prstDash val="solid"/>
+                      <a:round/>
+                      <a:headEnd type="none" w="med" len="med"/>
+                      <a:tailEnd type="none" w="med" len="med"/>
+                    </a:lnL>
+                    <a:lnR w="9525" cap="flat" cmpd="sng" algn="ctr">
+                      <a:solidFill>
+                        <a:srgbClr val="D5E0E3"/>
+                      </a:solidFill>
+                      <a:prstDash val="solid"/>
+                      <a:round/>
+                      <a:headEnd type="none" w="med" len="med"/>
+                      <a:tailEnd type="none" w="med" len="med"/>
+                    </a:lnR>
+                    <a:lnT w="9525" cap="flat" cmpd="sng" algn="ctr">
+                      <a:solidFill>
+                        <a:srgbClr val="D5E0E3"/>
+                      </a:solidFill>
+                      <a:prstDash val="solid"/>
+                      <a:round/>
+                      <a:headEnd type="none" w="med" len="med"/>
+                      <a:tailEnd type="none" w="med" len="med"/>
+                    </a:lnT>
+                    <a:lnB w="9525" cap="flat" cmpd="sng" algn="ctr">
+                      <a:solidFill>
+                        <a:srgbClr val="D5E0E3"/>
+                      </a:solidFill>
+                      <a:prstDash val="solid"/>
+                      <a:round/>
+                      <a:headEnd type="none" w="med" len="med"/>
+                      <a:tailEnd type="none" w="med" len="med"/>
+                    </a:lnB>
+                    <a:solidFill>
+                      <a:srgbClr val="F5F9FA"/>
+                    </a:solidFill>
+                  </a:tcPr>
+                </a:tc>
+                <a:tc>
+                  <a:txBody>
+                    <a:bodyPr/>
+                    <a:lstStyle/>
+                    <a:p>
+                      <a:pPr algn="r" indent="0" marL="0">
+                        <a:buNone/>
+                      </a:pPr>
+                      <a:r>
+                        <a:rPr lang="en-US" sz="1300" dirty="0">
+                          <a:solidFill>
+                            <a:srgbClr val="17232E"/>
+                          </a:solidFill>
+                        </a:rPr>
+                        <a:t>—</a:t>
+                      </a:r>
+                      <a:endParaRPr lang="en-US" sz="1300" dirty="0"/>
+                    </a:p>
+                  </a:txBody>
+                  <a:tcPr marL="73152" marR="73152" marT="27432" marB="27432" anchor="ctr">
+                    <a:lnL w="9525" cap="flat" cmpd="sng" algn="ctr">
+                      <a:solidFill>
+                        <a:srgbClr val="D5E0E3"/>
+                      </a:solidFill>
+                      <a:prstDash val="solid"/>
+                      <a:round/>
+                      <a:headEnd type="none" w="med" len="med"/>
+                      <a:tailEnd type="none" w="med" len="med"/>
+                    </a:lnL>
+                    <a:lnR w="9525" cap="flat" cmpd="sng" algn="ctr">
+                      <a:solidFill>
+                        <a:srgbClr val="D5E0E3"/>
+                      </a:solidFill>
+                      <a:prstDash val="solid"/>
+                      <a:round/>
+                      <a:headEnd type="none" w="med" len="med"/>
+                      <a:tailEnd type="none" w="med" len="med"/>
+                    </a:lnR>
+                    <a:lnT w="9525" cap="flat" cmpd="sng" algn="ctr">
+                      <a:solidFill>
+                        <a:srgbClr val="D5E0E3"/>
+                      </a:solidFill>
+                      <a:prstDash val="solid"/>
+                      <a:round/>
+                      <a:headEnd type="none" w="med" len="med"/>
+                      <a:tailEnd type="none" w="med" len="med"/>
+                    </a:lnT>
+                    <a:lnB w="9525" cap="flat" cmpd="sng" algn="ctr">
+                      <a:solidFill>
+                        <a:srgbClr val="D5E0E3"/>
+                      </a:solidFill>
+                      <a:prstDash val="solid"/>
+                      <a:round/>
+                      <a:headEnd type="none" w="med" len="med"/>
+                      <a:tailEnd type="none" w="med" len="med"/>
+                    </a:lnB>
+                    <a:solidFill>
+                      <a:srgbClr val="F5F9FA"/>
+                    </a:solidFill>
+                  </a:tcPr>
+                </a:tc>
+              </a:tr>
+              <a:tr h="457200">
+                <a:tc>
+                  <a:txBody>
+                    <a:bodyPr/>
+                    <a:lstStyle/>
+                    <a:p>
+                      <a:pPr algn="l" indent="0" marL="0">
+                        <a:buNone/>
+                      </a:pPr>
+                      <a:r>
+                        <a:rPr lang="en-US" sz="1300" b="1" dirty="0">
+                          <a:solidFill>
+                            <a:srgbClr val="17232E"/>
+                          </a:solidFill>
+                        </a:rPr>
+                        <a:t>Stock count &amp; data validation</a:t>
+                      </a:r>
+                      <a:endParaRPr lang="en-US" sz="1300" dirty="0"/>
+                    </a:p>
+                  </a:txBody>
+                  <a:tcPr marL="73152" marR="73152" marT="27432" marB="27432" anchor="ctr">
+                    <a:lnL w="9525" cap="flat" cmpd="sng" algn="ctr">
+                      <a:solidFill>
+                        <a:srgbClr val="D5E0E3"/>
+                      </a:solidFill>
+                      <a:prstDash val="solid"/>
+                      <a:round/>
+                      <a:headEnd type="none" w="med" len="med"/>
+                      <a:tailEnd type="none" w="med" len="med"/>
+                    </a:lnL>
+                    <a:lnR w="9525" cap="flat" cmpd="sng" algn="ctr">
+                      <a:solidFill>
+                        <a:srgbClr val="D5E0E3"/>
+                      </a:solidFill>
+                      <a:prstDash val="solid"/>
+                      <a:round/>
+                      <a:headEnd type="none" w="med" len="med"/>
+                      <a:tailEnd type="none" w="med" len="med"/>
+                    </a:lnR>
+                    <a:lnT w="9525" cap="flat" cmpd="sng" algn="ctr">
+                      <a:solidFill>
+                        <a:srgbClr val="D5E0E3"/>
+                      </a:solidFill>
+                      <a:prstDash val="solid"/>
+                      <a:round/>
+                      <a:headEnd type="none" w="med" len="med"/>
+                      <a:tailEnd type="none" w="med" len="med"/>
+                    </a:lnT>
+                    <a:lnB w="9525" cap="flat" cmpd="sng" algn="ctr">
+                      <a:solidFill>
+                        <a:srgbClr val="D5E0E3"/>
+                      </a:solidFill>
+                      <a:prstDash val="solid"/>
+                      <a:round/>
+                      <a:headEnd type="none" w="med" len="med"/>
+                      <a:tailEnd type="none" w="med" len="med"/>
+                    </a:lnB>
+                    <a:solidFill>
+                      <a:srgbClr val="FFFFFF"/>
+                    </a:solidFill>
+                  </a:tcPr>
+                </a:tc>
+                <a:tc>
+                  <a:txBody>
+                    <a:bodyPr/>
+                    <a:lstStyle/>
+                    <a:p>
+                      <a:pPr algn="l" indent="0" marL="0">
+                        <a:buNone/>
+                      </a:pPr>
+                      <a:r>
+                        <a:rPr lang="en-US" sz="1300" dirty="0">
+                          <a:solidFill>
+                            <a:srgbClr val="17232E"/>
+                          </a:solidFill>
+                        </a:rPr>
+                        <a:t>80 h × $40/h (needed with either option)</a:t>
+                      </a:r>
+                      <a:endParaRPr lang="en-US" sz="1300" dirty="0"/>
+                    </a:p>
+                  </a:txBody>
+                  <a:tcPr marL="73152" marR="73152" marT="27432" marB="27432" anchor="ctr">
+                    <a:lnL w="9525" cap="flat" cmpd="sng" algn="ctr">
+                      <a:solidFill>
+                        <a:srgbClr val="D5E0E3"/>
+                      </a:solidFill>
+                      <a:prstDash val="solid"/>
+                      <a:round/>
+                      <a:headEnd type="none" w="med" len="med"/>
+                      <a:tailEnd type="none" w="med" len="med"/>
+                    </a:lnL>
+                    <a:lnR w="9525" cap="flat" cmpd="sng" algn="ctr">
+                      <a:solidFill>
+                        <a:srgbClr val="D5E0E3"/>
+                      </a:solidFill>
+                      <a:prstDash val="solid"/>
+                      <a:round/>
+                      <a:headEnd type="none" w="med" len="med"/>
+                      <a:tailEnd type="none" w="med" len="med"/>
+                    </a:lnR>
+                    <a:lnT w="9525" cap="flat" cmpd="sng" algn="ctr">
+                      <a:solidFill>
+                        <a:srgbClr val="D5E0E3"/>
+                      </a:solidFill>
+                      <a:prstDash val="solid"/>
+                      <a:round/>
+                      <a:headEnd type="none" w="med" len="med"/>
+                      <a:tailEnd type="none" w="med" len="med"/>
+                    </a:lnT>
+                    <a:lnB w="9525" cap="flat" cmpd="sng" algn="ctr">
+                      <a:solidFill>
+                        <a:srgbClr val="D5E0E3"/>
+                      </a:solidFill>
+                      <a:prstDash val="solid"/>
+                      <a:round/>
+                      <a:headEnd type="none" w="med" len="med"/>
+                      <a:tailEnd type="none" w="med" len="med"/>
+                    </a:lnB>
+                    <a:solidFill>
+                      <a:srgbClr val="FFFFFF"/>
+                    </a:solidFill>
+                  </a:tcPr>
+                </a:tc>
+                <a:tc>
+                  <a:txBody>
+                    <a:bodyPr/>
+                    <a:lstStyle/>
+                    <a:p>
+                      <a:pPr algn="r" indent="0" marL="0">
+                        <a:buNone/>
+                      </a:pPr>
+                      <a:r>
+                        <a:rPr lang="en-US" sz="1300" dirty="0">
+                          <a:solidFill>
+                            <a:srgbClr val="17232E"/>
+                          </a:solidFill>
+                        </a:rPr>
+                        <a:t>$3,200</a:t>
+                      </a:r>
+                      <a:endParaRPr lang="en-US" sz="1300" dirty="0"/>
+                    </a:p>
+                  </a:txBody>
+                  <a:tcPr marL="73152" marR="73152" marT="27432" marB="27432" anchor="ctr">
+                    <a:lnL w="9525" cap="flat" cmpd="sng" algn="ctr">
+                      <a:solidFill>
+                        <a:srgbClr val="D5E0E3"/>
+                      </a:solidFill>
+                      <a:prstDash val="solid"/>
+                      <a:round/>
+                      <a:headEnd type="none" w="med" len="med"/>
+                      <a:tailEnd type="none" w="med" len="med"/>
+                    </a:lnL>
+                    <a:lnR w="9525" cap="flat" cmpd="sng" algn="ctr">
+                      <a:solidFill>
+                        <a:srgbClr val="D5E0E3"/>
+                      </a:solidFill>
+                      <a:prstDash val="solid"/>
+                      <a:round/>
+                      <a:headEnd type="none" w="med" len="med"/>
+                      <a:tailEnd type="none" w="med" len="med"/>
+                    </a:lnR>
+                    <a:lnT w="9525" cap="flat" cmpd="sng" algn="ctr">
+                      <a:solidFill>
+                        <a:srgbClr val="D5E0E3"/>
+                      </a:solidFill>
+                      <a:prstDash val="solid"/>
+                      <a:round/>
+                      <a:headEnd type="none" w="med" len="med"/>
+                      <a:tailEnd type="none" w="med" len="med"/>
+                    </a:lnT>
+                    <a:lnB w="9525" cap="flat" cmpd="sng" algn="ctr">
+                      <a:solidFill>
+                        <a:srgbClr val="D5E0E3"/>
+                      </a:solidFill>
+                      <a:prstDash val="solid"/>
+                      <a:round/>
+                      <a:headEnd type="none" w="med" len="med"/>
+                      <a:tailEnd type="none" w="med" len="med"/>
+                    </a:lnB>
+                    <a:solidFill>
+                      <a:srgbClr val="FFFFFF"/>
+                    </a:solidFill>
+                  </a:tcPr>
+                </a:tc>
+                <a:tc>
+                  <a:txBody>
+                    <a:bodyPr/>
+                    <a:lstStyle/>
+                    <a:p>
+                      <a:pPr algn="r" indent="0" marL="0">
+                        <a:buNone/>
+                      </a:pPr>
+                      <a:r>
+                        <a:rPr lang="en-US" sz="1300" dirty="0">
+                          <a:solidFill>
+                            <a:srgbClr val="17232E"/>
+                          </a:solidFill>
+                        </a:rPr>
+                        <a:t>—</a:t>
+                      </a:r>
+                      <a:endParaRPr lang="en-US" sz="1300" dirty="0"/>
+                    </a:p>
+                  </a:txBody>
+                  <a:tcPr marL="73152" marR="73152" marT="27432" marB="27432" anchor="ctr">
+                    <a:lnL w="9525" cap="flat" cmpd="sng" algn="ctr">
+                      <a:solidFill>
+                        <a:srgbClr val="D5E0E3"/>
+                      </a:solidFill>
+                      <a:prstDash val="solid"/>
+                      <a:round/>
+                      <a:headEnd type="none" w="med" len="med"/>
+                      <a:tailEnd type="none" w="med" len="med"/>
+                    </a:lnL>
+                    <a:lnR w="9525" cap="flat" cmpd="sng" algn="ctr">
+                      <a:solidFill>
+                        <a:srgbClr val="D5E0E3"/>
+                      </a:solidFill>
+                      <a:prstDash val="solid"/>
+                      <a:round/>
+                      <a:headEnd type="none" w="med" len="med"/>
+                      <a:tailEnd type="none" w="med" len="med"/>
+                    </a:lnR>
+                    <a:lnT w="9525" cap="flat" cmpd="sng" algn="ctr">
+                      <a:solidFill>
+                        <a:srgbClr val="D5E0E3"/>
+                      </a:solidFill>
+                      <a:prstDash val="solid"/>
+                      <a:round/>
+                      <a:headEnd type="none" w="med" len="med"/>
+                      <a:tailEnd type="none" w="med" len="med"/>
+                    </a:lnT>
+                    <a:lnB w="9525" cap="flat" cmpd="sng" algn="ctr">
+                      <a:solidFill>
+                        <a:srgbClr val="D5E0E3"/>
+                      </a:solidFill>
+                      <a:prstDash val="solid"/>
+                      <a:round/>
+                      <a:headEnd type="none" w="med" len="med"/>
+                      <a:tailEnd type="none" w="med" len="med"/>
+                    </a:lnB>
+                    <a:solidFill>
+                      <a:srgbClr val="FFFFFF"/>
+                    </a:solidFill>
+                  </a:tcPr>
+                </a:tc>
+              </a:tr>
+              <a:tr h="457200">
+                <a:tc>
+                  <a:txBody>
+                    <a:bodyPr/>
+                    <a:lstStyle/>
+                    <a:p>
+                      <a:pPr algn="l" indent="0" marL="0">
+                        <a:buNone/>
+                      </a:pPr>
+                      <a:r>
+                        <a:rPr lang="en-US" sz="1300" b="1" dirty="0">
+                          <a:solidFill>
+                            <a:srgbClr val="17232E"/>
+                          </a:solidFill>
+                        </a:rPr>
+                        <a:t>Training</a:t>
+                      </a:r>
+                      <a:endParaRPr lang="en-US" sz="1300" dirty="0"/>
+                    </a:p>
+                  </a:txBody>
+                  <a:tcPr marL="73152" marR="73152" marT="27432" marB="27432" anchor="ctr">
+                    <a:lnL w="9525" cap="flat" cmpd="sng" algn="ctr">
+                      <a:solidFill>
+                        <a:srgbClr val="D5E0E3"/>
+                      </a:solidFill>
+                      <a:prstDash val="solid"/>
+                      <a:round/>
+                      <a:headEnd type="none" w="med" len="med"/>
+                      <a:tailEnd type="none" w="med" len="med"/>
+                    </a:lnL>
+                    <a:lnR w="9525" cap="flat" cmpd="sng" algn="ctr">
+                      <a:solidFill>
+                        <a:srgbClr val="D5E0E3"/>
+                      </a:solidFill>
+                      <a:prstDash val="solid"/>
+                      <a:round/>
+                      <a:headEnd type="none" w="med" len="med"/>
+                      <a:tailEnd type="none" w="med" len="med"/>
+                    </a:lnR>
+                    <a:lnT w="9525" cap="flat" cmpd="sng" algn="ctr">
+                      <a:solidFill>
+                        <a:srgbClr val="D5E0E3"/>
+                      </a:solidFill>
+                      <a:prstDash val="solid"/>
+                      <a:round/>
+                      <a:headEnd type="none" w="med" len="med"/>
+                      <a:tailEnd type="none" w="med" len="med"/>
+                    </a:lnT>
+                    <a:lnB w="9525" cap="flat" cmpd="sng" algn="ctr">
+                      <a:solidFill>
+                        <a:srgbClr val="D5E0E3"/>
+                      </a:solidFill>
+                      <a:prstDash val="solid"/>
+                      <a:round/>
+                      <a:headEnd type="none" w="med" len="med"/>
+                      <a:tailEnd type="none" w="med" len="med"/>
+                    </a:lnB>
+                    <a:solidFill>
+                      <a:srgbClr val="F5F9FA"/>
+                    </a:solidFill>
+                  </a:tcPr>
+                </a:tc>
+                <a:tc>
+                  <a:txBody>
+                    <a:bodyPr/>
+                    <a:lstStyle/>
+                    <a:p>
+                      <a:pPr algn="l" indent="0" marL="0">
+                        <a:buNone/>
+                      </a:pPr>
+                      <a:r>
+                        <a:rPr lang="en-US" sz="1300" dirty="0">
+                          <a:solidFill>
+                            <a:srgbClr val="17232E"/>
+                          </a:solidFill>
+                        </a:rPr>
+                        <a:t>62 people × 1 h × $40/h (either option)</a:t>
+                      </a:r>
+                      <a:endParaRPr lang="en-US" sz="1300" dirty="0"/>
+                    </a:p>
+                  </a:txBody>
+                  <a:tcPr marL="73152" marR="73152" marT="27432" marB="27432" anchor="ctr">
+                    <a:lnL w="9525" cap="flat" cmpd="sng" algn="ctr">
+                      <a:solidFill>
+                        <a:srgbClr val="D5E0E3"/>
+                      </a:solidFill>
+                      <a:prstDash val="solid"/>
+                      <a:round/>
+                      <a:headEnd type="none" w="med" len="med"/>
+                      <a:tailEnd type="none" w="med" len="med"/>
+                    </a:lnL>
+                    <a:lnR w="9525" cap="flat" cmpd="sng" algn="ctr">
+                      <a:solidFill>
+                        <a:srgbClr val="D5E0E3"/>
+                      </a:solidFill>
+                      <a:prstDash val="solid"/>
+                      <a:round/>
+                      <a:headEnd type="none" w="med" len="med"/>
+                      <a:tailEnd type="none" w="med" len="med"/>
+                    </a:lnR>
+                    <a:lnT w="9525" cap="flat" cmpd="sng" algn="ctr">
+                      <a:solidFill>
+                        <a:srgbClr val="D5E0E3"/>
+                      </a:solidFill>
+                      <a:prstDash val="solid"/>
+                      <a:round/>
+                      <a:headEnd type="none" w="med" len="med"/>
+                      <a:tailEnd type="none" w="med" len="med"/>
+                    </a:lnT>
+                    <a:lnB w="9525" cap="flat" cmpd="sng" algn="ctr">
+                      <a:solidFill>
+                        <a:srgbClr val="D5E0E3"/>
+                      </a:solidFill>
+                      <a:prstDash val="solid"/>
+                      <a:round/>
+                      <a:headEnd type="none" w="med" len="med"/>
+                      <a:tailEnd type="none" w="med" len="med"/>
+                    </a:lnB>
+                    <a:solidFill>
+                      <a:srgbClr val="F5F9FA"/>
+                    </a:solidFill>
+                  </a:tcPr>
+                </a:tc>
+                <a:tc>
+                  <a:txBody>
+                    <a:bodyPr/>
+                    <a:lstStyle/>
+                    <a:p>
+                      <a:pPr algn="r" indent="0" marL="0">
+                        <a:buNone/>
+                      </a:pPr>
+                      <a:r>
+                        <a:rPr lang="en-US" sz="1300" dirty="0">
+                          <a:solidFill>
+                            <a:srgbClr val="17232E"/>
+                          </a:solidFill>
+                        </a:rPr>
+                        <a:t>$2,480</a:t>
+                      </a:r>
+                      <a:endParaRPr lang="en-US" sz="1300" dirty="0"/>
+                    </a:p>
+                  </a:txBody>
+                  <a:tcPr marL="73152" marR="73152" marT="27432" marB="27432" anchor="ctr">
+                    <a:lnL w="9525" cap="flat" cmpd="sng" algn="ctr">
+                      <a:solidFill>
+                        <a:srgbClr val="D5E0E3"/>
+                      </a:solidFill>
+                      <a:prstDash val="solid"/>
+                      <a:round/>
+                      <a:headEnd type="none" w="med" len="med"/>
+                      <a:tailEnd type="none" w="med" len="med"/>
+                    </a:lnL>
+                    <a:lnR w="9525" cap="flat" cmpd="sng" algn="ctr">
+                      <a:solidFill>
+                        <a:srgbClr val="D5E0E3"/>
+                      </a:solidFill>
+                      <a:prstDash val="solid"/>
+                      <a:round/>
+                      <a:headEnd type="none" w="med" len="med"/>
+                      <a:tailEnd type="none" w="med" len="med"/>
+                    </a:lnR>
+                    <a:lnT w="9525" cap="flat" cmpd="sng" algn="ctr">
+                      <a:solidFill>
+                        <a:srgbClr val="D5E0E3"/>
+                      </a:solidFill>
+                      <a:prstDash val="solid"/>
+                      <a:round/>
+                      <a:headEnd type="none" w="med" len="med"/>
+                      <a:tailEnd type="none" w="med" len="med"/>
+                    </a:lnT>
+                    <a:lnB w="9525" cap="flat" cmpd="sng" algn="ctr">
+                      <a:solidFill>
+                        <a:srgbClr val="D5E0E3"/>
+                      </a:solidFill>
+                      <a:prstDash val="solid"/>
+                      <a:round/>
+                      <a:headEnd type="none" w="med" len="med"/>
+                      <a:tailEnd type="none" w="med" len="med"/>
+                    </a:lnB>
+                    <a:solidFill>
+                      <a:srgbClr val="F5F9FA"/>
+                    </a:solidFill>
+                  </a:tcPr>
+                </a:tc>
+                <a:tc>
+                  <a:txBody>
+                    <a:bodyPr/>
+                    <a:lstStyle/>
+                    <a:p>
+                      <a:pPr algn="r" indent="0" marL="0">
+                        <a:buNone/>
+                      </a:pPr>
+                      <a:r>
+                        <a:rPr lang="en-US" sz="1300" dirty="0">
+                          <a:solidFill>
+                            <a:srgbClr val="17232E"/>
+                          </a:solidFill>
+                        </a:rPr>
+                        <a:t>—</a:t>
+                      </a:r>
+                      <a:endParaRPr lang="en-US" sz="1300" dirty="0"/>
+                    </a:p>
+                  </a:txBody>
+                  <a:tcPr marL="73152" marR="73152" marT="27432" marB="27432" anchor="ctr">
+                    <a:lnL w="9525" cap="flat" cmpd="sng" algn="ctr">
+                      <a:solidFill>
+                        <a:srgbClr val="D5E0E3"/>
+                      </a:solidFill>
+                      <a:prstDash val="solid"/>
+                      <a:round/>
+                      <a:headEnd type="none" w="med" len="med"/>
+                      <a:tailEnd type="none" w="med" len="med"/>
+                    </a:lnL>
+                    <a:lnR w="9525" cap="flat" cmpd="sng" algn="ctr">
+                      <a:solidFill>
+                        <a:srgbClr val="D5E0E3"/>
+                      </a:solidFill>
+                      <a:prstDash val="solid"/>
+                      <a:round/>
+                      <a:headEnd type="none" w="med" len="med"/>
+                      <a:tailEnd type="none" w="med" len="med"/>
+                    </a:lnR>
+                    <a:lnT w="9525" cap="flat" cmpd="sng" algn="ctr">
+                      <a:solidFill>
+                        <a:srgbClr val="D5E0E3"/>
+                      </a:solidFill>
+                      <a:prstDash val="solid"/>
+                      <a:round/>
+                      <a:headEnd type="none" w="med" len="med"/>
+                      <a:tailEnd type="none" w="med" len="med"/>
+                    </a:lnT>
+                    <a:lnB w="9525" cap="flat" cmpd="sng" algn="ctr">
+                      <a:solidFill>
+                        <a:srgbClr val="D5E0E3"/>
+                      </a:solidFill>
+                      <a:prstDash val="solid"/>
+                      <a:round/>
+                      <a:headEnd type="none" w="med" len="med"/>
+                      <a:tailEnd type="none" w="med" len="med"/>
+                    </a:lnB>
+                    <a:solidFill>
+                      <a:srgbClr val="F5F9FA"/>
+                    </a:solidFill>
+                  </a:tcPr>
+                </a:tc>
+              </a:tr>
+              <a:tr h="457200">
+                <a:tc>
+                  <a:txBody>
+                    <a:bodyPr/>
+                    <a:lstStyle/>
+                    <a:p>
+                      <a:pPr algn="l" indent="0" marL="0">
+                        <a:buNone/>
+                      </a:pPr>
+                      <a:r>
+                        <a:rPr lang="en-US" sz="1300" b="1" dirty="0">
+                          <a:solidFill>
+                            <a:srgbClr val="17232E"/>
+                          </a:solidFill>
+                        </a:rPr>
+                        <a:t>Server / VM hosting &amp; backup storage</a:t>
+                      </a:r>
+                      <a:endParaRPr lang="en-US" sz="1300" dirty="0"/>
+                    </a:p>
+                  </a:txBody>
+                  <a:tcPr marL="73152" marR="73152" marT="27432" marB="27432" anchor="ctr">
+                    <a:lnL w="9525" cap="flat" cmpd="sng" algn="ctr">
+                      <a:solidFill>
+                        <a:srgbClr val="D5E0E3"/>
+                      </a:solidFill>
+                      <a:prstDash val="solid"/>
+                      <a:round/>
+                      <a:headEnd type="none" w="med" len="med"/>
+                      <a:tailEnd type="none" w="med" len="med"/>
+                    </a:lnL>
+                    <a:lnR w="9525" cap="flat" cmpd="sng" algn="ctr">
+                      <a:solidFill>
+                        <a:srgbClr val="D5E0E3"/>
+                      </a:solidFill>
+                      <a:prstDash val="solid"/>
+                      <a:round/>
+                      <a:headEnd type="none" w="med" len="med"/>
+                      <a:tailEnd type="none" w="med" len="med"/>
+                    </a:lnR>
+                    <a:lnT w="9525" cap="flat" cmpd="sng" algn="ctr">
+                      <a:solidFill>
+                        <a:srgbClr val="D5E0E3"/>
+                      </a:solidFill>
+                      <a:prstDash val="solid"/>
+                      <a:round/>
+                      <a:headEnd type="none" w="med" len="med"/>
+                      <a:tailEnd type="none" w="med" len="med"/>
+                    </a:lnT>
+                    <a:lnB w="9525" cap="flat" cmpd="sng" algn="ctr">
+                      <a:solidFill>
+                        <a:srgbClr val="D5E0E3"/>
+                      </a:solidFill>
+                      <a:prstDash val="solid"/>
+                      <a:round/>
+                      <a:headEnd type="none" w="med" len="med"/>
+                      <a:tailEnd type="none" w="med" len="med"/>
+                    </a:lnB>
+                    <a:solidFill>
+                      <a:srgbClr val="FFFFFF"/>
+                    </a:solidFill>
+                  </a:tcPr>
+                </a:tc>
+                <a:tc>
+                  <a:txBody>
+                    <a:bodyPr/>
+                    <a:lstStyle/>
+                    <a:p>
+                      <a:pPr algn="l" indent="0" marL="0">
+                        <a:buNone/>
+                      </a:pPr>
+                      <a:r>
+                        <a:rPr lang="en-US" sz="1300" dirty="0">
+                          <a:solidFill>
+                            <a:srgbClr val="17232E"/>
+                          </a:solidFill>
+                        </a:rPr>
+                        <a:t>Small internal VM + off-host backups</a:t>
+                      </a:r>
+                      <a:endParaRPr lang="en-US" sz="1300" dirty="0"/>
+                    </a:p>
+                  </a:txBody>
+                  <a:tcPr marL="73152" marR="73152" marT="27432" marB="27432" anchor="ctr">
+                    <a:lnL w="9525" cap="flat" cmpd="sng" algn="ctr">
+                      <a:solidFill>
+                        <a:srgbClr val="D5E0E3"/>
+                      </a:solidFill>
+                      <a:prstDash val="solid"/>
+                      <a:round/>
+                      <a:headEnd type="none" w="med" len="med"/>
+                      <a:tailEnd type="none" w="med" len="med"/>
+                    </a:lnL>
+                    <a:lnR w="9525" cap="flat" cmpd="sng" algn="ctr">
+                      <a:solidFill>
+                        <a:srgbClr val="D5E0E3"/>
+                      </a:solidFill>
+                      <a:prstDash val="solid"/>
+                      <a:round/>
+                      <a:headEnd type="none" w="med" len="med"/>
+                      <a:tailEnd type="none" w="med" len="med"/>
+                    </a:lnR>
+                    <a:lnT w="9525" cap="flat" cmpd="sng" algn="ctr">
+                      <a:solidFill>
+                        <a:srgbClr val="D5E0E3"/>
+                      </a:solidFill>
+                      <a:prstDash val="solid"/>
+                      <a:round/>
+                      <a:headEnd type="none" w="med" len="med"/>
+                      <a:tailEnd type="none" w="med" len="med"/>
+                    </a:lnT>
+                    <a:lnB w="9525" cap="flat" cmpd="sng" algn="ctr">
+                      <a:solidFill>
+                        <a:srgbClr val="D5E0E3"/>
+                      </a:solidFill>
+                      <a:prstDash val="solid"/>
+                      <a:round/>
+                      <a:headEnd type="none" w="med" len="med"/>
+                      <a:tailEnd type="none" w="med" len="med"/>
+                    </a:lnB>
+                    <a:solidFill>
+                      <a:srgbClr val="FFFFFF"/>
+                    </a:solidFill>
+                  </a:tcPr>
+                </a:tc>
+                <a:tc>
+                  <a:txBody>
+                    <a:bodyPr/>
+                    <a:lstStyle/>
+                    <a:p>
+                      <a:pPr algn="r" indent="0" marL="0">
+                        <a:buNone/>
+                      </a:pPr>
+                      <a:r>
+                        <a:rPr lang="en-US" sz="1300" dirty="0">
+                          <a:solidFill>
+                            <a:srgbClr val="17232E"/>
+                          </a:solidFill>
+                        </a:rPr>
+                        <a:t>$1,200</a:t>
+                      </a:r>
+                      <a:endParaRPr lang="en-US" sz="1300" dirty="0"/>
+                    </a:p>
+                  </a:txBody>
+                  <a:tcPr marL="73152" marR="73152" marT="27432" marB="27432" anchor="ctr">
+                    <a:lnL w="9525" cap="flat" cmpd="sng" algn="ctr">
+                      <a:solidFill>
+                        <a:srgbClr val="D5E0E3"/>
+                      </a:solidFill>
+                      <a:prstDash val="solid"/>
+                      <a:round/>
+                      <a:headEnd type="none" w="med" len="med"/>
+                      <a:tailEnd type="none" w="med" len="med"/>
+                    </a:lnL>
+                    <a:lnR w="9525" cap="flat" cmpd="sng" algn="ctr">
+                      <a:solidFill>
+                        <a:srgbClr val="D5E0E3"/>
+                      </a:solidFill>
+                      <a:prstDash val="solid"/>
+                      <a:round/>
+                      <a:headEnd type="none" w="med" len="med"/>
+                      <a:tailEnd type="none" w="med" len="med"/>
+                    </a:lnR>
+                    <a:lnT w="9525" cap="flat" cmpd="sng" algn="ctr">
+                      <a:solidFill>
+                        <a:srgbClr val="D5E0E3"/>
+                      </a:solidFill>
+                      <a:prstDash val="solid"/>
+                      <a:round/>
+                      <a:headEnd type="none" w="med" len="med"/>
+                      <a:tailEnd type="none" w="med" len="med"/>
+                    </a:lnT>
+                    <a:lnB w="9525" cap="flat" cmpd="sng" algn="ctr">
+                      <a:solidFill>
+                        <a:srgbClr val="D5E0E3"/>
+                      </a:solidFill>
+                      <a:prstDash val="solid"/>
+                      <a:round/>
+                      <a:headEnd type="none" w="med" len="med"/>
+                      <a:tailEnd type="none" w="med" len="med"/>
+                    </a:lnB>
+                    <a:solidFill>
+                      <a:srgbClr val="FFFFFF"/>
+                    </a:solidFill>
+                  </a:tcPr>
+                </a:tc>
+                <a:tc>
+                  <a:txBody>
+                    <a:bodyPr/>
+                    <a:lstStyle/>
+                    <a:p>
+                      <a:pPr algn="r" indent="0" marL="0">
+                        <a:buNone/>
+                      </a:pPr>
+                      <a:r>
+                        <a:rPr lang="en-US" sz="1300" dirty="0">
+                          <a:solidFill>
+                            <a:srgbClr val="17232E"/>
+                          </a:solidFill>
+                        </a:rPr>
+                        <a:t>$1,200</a:t>
+                      </a:r>
+                      <a:endParaRPr lang="en-US" sz="1300" dirty="0"/>
+                    </a:p>
+                  </a:txBody>
+                  <a:tcPr marL="73152" marR="73152" marT="27432" marB="27432" anchor="ctr">
+                    <a:lnL w="9525" cap="flat" cmpd="sng" algn="ctr">
+                      <a:solidFill>
+                        <a:srgbClr val="D5E0E3"/>
+                      </a:solidFill>
+                      <a:prstDash val="solid"/>
+                      <a:round/>
+                      <a:headEnd type="none" w="med" len="med"/>
+                      <a:tailEnd type="none" w="med" len="med"/>
+                    </a:lnL>
+                    <a:lnR w="9525" cap="flat" cmpd="sng" algn="ctr">
+                      <a:solidFill>
+                        <a:srgbClr val="D5E0E3"/>
+                      </a:solidFill>
+                      <a:prstDash val="solid"/>
+                      <a:round/>
+                      <a:headEnd type="none" w="med" len="med"/>
+                      <a:tailEnd type="none" w="med" len="med"/>
+                    </a:lnR>
+                    <a:lnT w="9525" cap="flat" cmpd="sng" algn="ctr">
+                      <a:solidFill>
+                        <a:srgbClr val="D5E0E3"/>
+                      </a:solidFill>
+                      <a:prstDash val="solid"/>
+                      <a:round/>
+                      <a:headEnd type="none" w="med" len="med"/>
+                      <a:tailEnd type="none" w="med" len="med"/>
+                    </a:lnT>
+                    <a:lnB w="9525" cap="flat" cmpd="sng" algn="ctr">
+                      <a:solidFill>
+                        <a:srgbClr val="D5E0E3"/>
+                      </a:solidFill>
+                      <a:prstDash val="solid"/>
+                      <a:round/>
+                      <a:headEnd type="none" w="med" len="med"/>
+                      <a:tailEnd type="none" w="med" len="med"/>
+                    </a:lnB>
+                    <a:solidFill>
+                      <a:srgbClr val="FFFFFF"/>
+                    </a:solidFill>
+                  </a:tcPr>
+                </a:tc>
+              </a:tr>
+              <a:tr h="457200">
+                <a:tc>
+                  <a:txBody>
+                    <a:bodyPr/>
+                    <a:lstStyle/>
+                    <a:p>
+                      <a:pPr algn="l" indent="0" marL="0">
+                        <a:buNone/>
+                      </a:pPr>
+                      <a:r>
+                        <a:rPr lang="en-US" sz="1300" b="1" dirty="0">
+                          <a:solidFill>
+                            <a:srgbClr val="17232E"/>
+                          </a:solidFill>
+                        </a:rPr>
+                        <a:t>Support, patching &amp; small changes</a:t>
+                      </a:r>
+                      <a:endParaRPr lang="en-US" sz="1300" dirty="0"/>
+                    </a:p>
+                  </a:txBody>
+                  <a:tcPr marL="73152" marR="73152" marT="27432" marB="27432" anchor="ctr">
+                    <a:lnL w="9525" cap="flat" cmpd="sng" algn="ctr">
+                      <a:solidFill>
+                        <a:srgbClr val="D5E0E3"/>
+                      </a:solidFill>
+                      <a:prstDash val="solid"/>
+                      <a:round/>
+                      <a:headEnd type="none" w="med" len="med"/>
+                      <a:tailEnd type="none" w="med" len="med"/>
+                    </a:lnL>
+                    <a:lnR w="9525" cap="flat" cmpd="sng" algn="ctr">
+                      <a:solidFill>
+                        <a:srgbClr val="D5E0E3"/>
+                      </a:solidFill>
+                      <a:prstDash val="solid"/>
+                      <a:round/>
+                      <a:headEnd type="none" w="med" len="med"/>
+                      <a:tailEnd type="none" w="med" len="med"/>
+                    </a:lnR>
+                    <a:lnT w="9525" cap="flat" cmpd="sng" algn="ctr">
+                      <a:solidFill>
+                        <a:srgbClr val="D5E0E3"/>
+                      </a:solidFill>
+                      <a:prstDash val="solid"/>
+                      <a:round/>
+                      <a:headEnd type="none" w="med" len="med"/>
+                      <a:tailEnd type="none" w="med" len="med"/>
+                    </a:lnT>
+                    <a:lnB w="9525" cap="flat" cmpd="sng" algn="ctr">
+                      <a:solidFill>
+                        <a:srgbClr val="D5E0E3"/>
+                      </a:solidFill>
+                      <a:prstDash val="solid"/>
+                      <a:round/>
+                      <a:headEnd type="none" w="med" len="med"/>
+                      <a:tailEnd type="none" w="med" len="med"/>
+                    </a:lnB>
+                    <a:solidFill>
+                      <a:srgbClr val="F5F9FA"/>
+                    </a:solidFill>
+                  </a:tcPr>
+                </a:tc>
+                <a:tc>
+                  <a:txBody>
+                    <a:bodyPr/>
+                    <a:lstStyle/>
+                    <a:p>
+                      <a:pPr algn="l" indent="0" marL="0">
+                        <a:buNone/>
+                      </a:pPr>
+                      <a:r>
+                        <a:rPr lang="en-US" sz="1300" dirty="0">
+                          <a:solidFill>
+                            <a:srgbClr val="17232E"/>
+                          </a:solidFill>
+                        </a:rPr>
+                        <a:t>4 h/week × 52 × $40/h</a:t>
+                      </a:r>
+                      <a:endParaRPr lang="en-US" sz="1300" dirty="0"/>
+                    </a:p>
+                  </a:txBody>
+                  <a:tcPr marL="73152" marR="73152" marT="27432" marB="27432" anchor="ctr">
+                    <a:lnL w="9525" cap="flat" cmpd="sng" algn="ctr">
+                      <a:solidFill>
+                        <a:srgbClr val="D5E0E3"/>
+                      </a:solidFill>
+                      <a:prstDash val="solid"/>
+                      <a:round/>
+                      <a:headEnd type="none" w="med" len="med"/>
+                      <a:tailEnd type="none" w="med" len="med"/>
+                    </a:lnL>
+                    <a:lnR w="9525" cap="flat" cmpd="sng" algn="ctr">
+                      <a:solidFill>
+                        <a:srgbClr val="D5E0E3"/>
+                      </a:solidFill>
+                      <a:prstDash val="solid"/>
+                      <a:round/>
+                      <a:headEnd type="none" w="med" len="med"/>
+                      <a:tailEnd type="none" w="med" len="med"/>
+                    </a:lnR>
+                    <a:lnT w="9525" cap="flat" cmpd="sng" algn="ctr">
+                      <a:solidFill>
+                        <a:srgbClr val="D5E0E3"/>
+                      </a:solidFill>
+                      <a:prstDash val="solid"/>
+                      <a:round/>
+                      <a:headEnd type="none" w="med" len="med"/>
+                      <a:tailEnd type="none" w="med" len="med"/>
+                    </a:lnT>
+                    <a:lnB w="9525" cap="flat" cmpd="sng" algn="ctr">
+                      <a:solidFill>
+                        <a:srgbClr val="D5E0E3"/>
+                      </a:solidFill>
+                      <a:prstDash val="solid"/>
+                      <a:round/>
+                      <a:headEnd type="none" w="med" len="med"/>
+                      <a:tailEnd type="none" w="med" len="med"/>
+                    </a:lnB>
+                    <a:solidFill>
+                      <a:srgbClr val="F5F9FA"/>
+                    </a:solidFill>
+                  </a:tcPr>
+                </a:tc>
+                <a:tc>
+                  <a:txBody>
+                    <a:bodyPr/>
+                    <a:lstStyle/>
+                    <a:p>
+                      <a:pPr algn="r" indent="0" marL="0">
+                        <a:buNone/>
+                      </a:pPr>
+                      <a:r>
+                        <a:rPr lang="en-US" sz="1300" dirty="0">
+                          <a:solidFill>
+                            <a:srgbClr val="17232E"/>
+                          </a:solidFill>
+                        </a:rPr>
+                        <a:t>$8,320</a:t>
+                      </a:r>
+                      <a:endParaRPr lang="en-US" sz="1300" dirty="0"/>
+                    </a:p>
+                  </a:txBody>
+                  <a:tcPr marL="73152" marR="73152" marT="27432" marB="27432" anchor="ctr">
+                    <a:lnL w="9525" cap="flat" cmpd="sng" algn="ctr">
+                      <a:solidFill>
+                        <a:srgbClr val="D5E0E3"/>
+                      </a:solidFill>
+                      <a:prstDash val="solid"/>
+                      <a:round/>
+                      <a:headEnd type="none" w="med" len="med"/>
+                      <a:tailEnd type="none" w="med" len="med"/>
+                    </a:lnL>
+                    <a:lnR w="9525" cap="flat" cmpd="sng" algn="ctr">
+                      <a:solidFill>
+                        <a:srgbClr val="D5E0E3"/>
+                      </a:solidFill>
+                      <a:prstDash val="solid"/>
+                      <a:round/>
+                      <a:headEnd type="none" w="med" len="med"/>
+                      <a:tailEnd type="none" w="med" len="med"/>
+                    </a:lnR>
+                    <a:lnT w="9525" cap="flat" cmpd="sng" algn="ctr">
+                      <a:solidFill>
+                        <a:srgbClr val="D5E0E3"/>
+                      </a:solidFill>
+                      <a:prstDash val="solid"/>
+                      <a:round/>
+                      <a:headEnd type="none" w="med" len="med"/>
+                      <a:tailEnd type="none" w="med" len="med"/>
+                    </a:lnT>
+                    <a:lnB w="9525" cap="flat" cmpd="sng" algn="ctr">
+                      <a:solidFill>
+                        <a:srgbClr val="D5E0E3"/>
+                      </a:solidFill>
+                      <a:prstDash val="solid"/>
+                      <a:round/>
+                      <a:headEnd type="none" w="med" len="med"/>
+                      <a:tailEnd type="none" w="med" len="med"/>
+                    </a:lnB>
+                    <a:solidFill>
+                      <a:srgbClr val="F5F9FA"/>
+                    </a:solidFill>
+                  </a:tcPr>
+                </a:tc>
+                <a:tc>
+                  <a:txBody>
+                    <a:bodyPr/>
+                    <a:lstStyle/>
+                    <a:p>
+                      <a:pPr algn="r" indent="0" marL="0">
+                        <a:buNone/>
+                      </a:pPr>
+                      <a:r>
+                        <a:rPr lang="en-US" sz="1300" dirty="0">
+                          <a:solidFill>
+                            <a:srgbClr val="17232E"/>
+                          </a:solidFill>
+                        </a:rPr>
+                        <a:t>$8,320</a:t>
+                      </a:r>
+                      <a:endParaRPr lang="en-US" sz="1300" dirty="0"/>
+                    </a:p>
+                  </a:txBody>
+                  <a:tcPr marL="73152" marR="73152" marT="27432" marB="27432" anchor="ctr">
+                    <a:lnL w="9525" cap="flat" cmpd="sng" algn="ctr">
+                      <a:solidFill>
+                        <a:srgbClr val="D5E0E3"/>
+                      </a:solidFill>
+                      <a:prstDash val="solid"/>
+                      <a:round/>
+                      <a:headEnd type="none" w="med" len="med"/>
+                      <a:tailEnd type="none" w="med" len="med"/>
+                    </a:lnL>
+                    <a:lnR w="9525" cap="flat" cmpd="sng" algn="ctr">
+                      <a:solidFill>
+                        <a:srgbClr val="D5E0E3"/>
+                      </a:solidFill>
+                      <a:prstDash val="solid"/>
+                      <a:round/>
+                      <a:headEnd type="none" w="med" len="med"/>
+                      <a:tailEnd type="none" w="med" len="med"/>
+                    </a:lnR>
+                    <a:lnT w="9525" cap="flat" cmpd="sng" algn="ctr">
+                      <a:solidFill>
+                        <a:srgbClr val="D5E0E3"/>
+                      </a:solidFill>
+                      <a:prstDash val="solid"/>
+                      <a:round/>
+                      <a:headEnd type="none" w="med" len="med"/>
+                      <a:tailEnd type="none" w="med" len="med"/>
+                    </a:lnT>
+                    <a:lnB w="9525" cap="flat" cmpd="sng" algn="ctr">
+                      <a:solidFill>
+                        <a:srgbClr val="D5E0E3"/>
+                      </a:solidFill>
+                      <a:prstDash val="solid"/>
+                      <a:round/>
+                      <a:headEnd type="none" w="med" len="med"/>
+                      <a:tailEnd type="none" w="med" len="med"/>
+                    </a:lnB>
+                    <a:solidFill>
+                      <a:srgbClr val="F5F9FA"/>
+                    </a:solidFill>
+                  </a:tcPr>
+                </a:tc>
+              </a:tr>
+              <a:tr h="457200">
+                <a:tc>
+                  <a:txBody>
+                    <a:bodyPr/>
+                    <a:lstStyle/>
+                    <a:p>
+                      <a:pPr algn="l" indent="0" marL="0">
+                        <a:buNone/>
+                      </a:pPr>
+                      <a:r>
+                        <a:rPr lang="en-US" sz="1300" b="1" dirty="0">
+                          <a:solidFill>
+                            <a:srgbClr val="17232E"/>
+                          </a:solidFill>
+                        </a:rPr>
+                        <a:t>Licences</a:t>
+                      </a:r>
+                      <a:endParaRPr lang="en-US" sz="1300" dirty="0"/>
+                    </a:p>
+                  </a:txBody>
+                  <a:tcPr marL="73152" marR="73152" marT="27432" marB="27432" anchor="ctr">
+                    <a:lnL w="9525" cap="flat" cmpd="sng" algn="ctr">
+                      <a:solidFill>
+                        <a:srgbClr val="D5E0E3"/>
+                      </a:solidFill>
+                      <a:prstDash val="solid"/>
+                      <a:round/>
+                      <a:headEnd type="none" w="med" len="med"/>
+                      <a:tailEnd type="none" w="med" len="med"/>
+                    </a:lnL>
+                    <a:lnR w="9525" cap="flat" cmpd="sng" algn="ctr">
+                      <a:solidFill>
+                        <a:srgbClr val="D5E0E3"/>
+                      </a:solidFill>
+                      <a:prstDash val="solid"/>
+                      <a:round/>
+                      <a:headEnd type="none" w="med" len="med"/>
+                      <a:tailEnd type="none" w="med" len="med"/>
+                    </a:lnR>
+                    <a:lnT w="9525" cap="flat" cmpd="sng" algn="ctr">
+                      <a:solidFill>
+                        <a:srgbClr val="D5E0E3"/>
+                      </a:solidFill>
+                      <a:prstDash val="solid"/>
+                      <a:round/>
+                      <a:headEnd type="none" w="med" len="med"/>
+                      <a:tailEnd type="none" w="med" len="med"/>
+                    </a:lnT>
+                    <a:lnB w="9525" cap="flat" cmpd="sng" algn="ctr">
+                      <a:solidFill>
+                        <a:srgbClr val="D5E0E3"/>
+                      </a:solidFill>
+                      <a:prstDash val="solid"/>
+                      <a:round/>
+                      <a:headEnd type="none" w="med" len="med"/>
+                      <a:tailEnd type="none" w="med" len="med"/>
+                    </a:lnB>
+                    <a:solidFill>
+                      <a:srgbClr val="FFFFFF"/>
+                    </a:solidFill>
+                  </a:tcPr>
+                </a:tc>
+                <a:tc>
+                  <a:txBody>
+                    <a:bodyPr/>
+                    <a:lstStyle/>
+                    <a:p>
+                      <a:pPr algn="l" indent="0" marL="0">
+                        <a:buNone/>
+                      </a:pPr>
+                      <a:r>
+                        <a:rPr lang="en-US" sz="1300" dirty="0">
+                          <a:solidFill>
+                            <a:srgbClr val="17232E"/>
+                          </a:solidFill>
+                        </a:rPr>
+                        <a:t>0 × 62 users</a:t>
+                      </a:r>
+                      <a:endParaRPr lang="en-US" sz="1300" dirty="0"/>
+                    </a:p>
+                  </a:txBody>
+                  <a:tcPr marL="73152" marR="73152" marT="27432" marB="27432" anchor="ctr">
+                    <a:lnL w="9525" cap="flat" cmpd="sng" algn="ctr">
+                      <a:solidFill>
+                        <a:srgbClr val="D5E0E3"/>
+                      </a:solidFill>
+                      <a:prstDash val="solid"/>
+                      <a:round/>
+                      <a:headEnd type="none" w="med" len="med"/>
+                      <a:tailEnd type="none" w="med" len="med"/>
+                    </a:lnL>
+                    <a:lnR w="9525" cap="flat" cmpd="sng" algn="ctr">
+                      <a:solidFill>
+                        <a:srgbClr val="D5E0E3"/>
+                      </a:solidFill>
+                      <a:prstDash val="solid"/>
+                      <a:round/>
+                      <a:headEnd type="none" w="med" len="med"/>
+                      <a:tailEnd type="none" w="med" len="med"/>
+                    </a:lnR>
+                    <a:lnT w="9525" cap="flat" cmpd="sng" algn="ctr">
+                      <a:solidFill>
+                        <a:srgbClr val="D5E0E3"/>
+                      </a:solidFill>
+                      <a:prstDash val="solid"/>
+                      <a:round/>
+                      <a:headEnd type="none" w="med" len="med"/>
+                      <a:tailEnd type="none" w="med" len="med"/>
+                    </a:lnT>
+                    <a:lnB w="9525" cap="flat" cmpd="sng" algn="ctr">
+                      <a:solidFill>
+                        <a:srgbClr val="D5E0E3"/>
+                      </a:solidFill>
+                      <a:prstDash val="solid"/>
+                      <a:round/>
+                      <a:headEnd type="none" w="med" len="med"/>
+                      <a:tailEnd type="none" w="med" len="med"/>
+                    </a:lnB>
+                    <a:solidFill>
+                      <a:srgbClr val="FFFFFF"/>
+                    </a:solidFill>
+                  </a:tcPr>
+                </a:tc>
+                <a:tc>
+                  <a:txBody>
+                    <a:bodyPr/>
+                    <a:lstStyle/>
+                    <a:p>
+                      <a:pPr algn="r" indent="0" marL="0">
+                        <a:buNone/>
+                      </a:pPr>
+                      <a:r>
+                        <a:rPr lang="en-US" sz="1300" dirty="0">
+                          <a:solidFill>
+                            <a:srgbClr val="17232E"/>
+                          </a:solidFill>
+                        </a:rPr>
+                        <a:t>$0</a:t>
+                      </a:r>
+                      <a:endParaRPr lang="en-US" sz="1300" dirty="0"/>
+                    </a:p>
+                  </a:txBody>
+                  <a:tcPr marL="73152" marR="73152" marT="27432" marB="27432" anchor="ctr">
+                    <a:lnL w="9525" cap="flat" cmpd="sng" algn="ctr">
+                      <a:solidFill>
+                        <a:srgbClr val="D5E0E3"/>
+                      </a:solidFill>
+                      <a:prstDash val="solid"/>
+                      <a:round/>
+                      <a:headEnd type="none" w="med" len="med"/>
+                      <a:tailEnd type="none" w="med" len="med"/>
+                    </a:lnL>
+                    <a:lnR w="9525" cap="flat" cmpd="sng" algn="ctr">
+                      <a:solidFill>
+                        <a:srgbClr val="D5E0E3"/>
+                      </a:solidFill>
+                      <a:prstDash val="solid"/>
+                      <a:round/>
+                      <a:headEnd type="none" w="med" len="med"/>
+                      <a:tailEnd type="none" w="med" len="med"/>
+                    </a:lnR>
+                    <a:lnT w="9525" cap="flat" cmpd="sng" algn="ctr">
+                      <a:solidFill>
+                        <a:srgbClr val="D5E0E3"/>
+                      </a:solidFill>
+                      <a:prstDash val="solid"/>
+                      <a:round/>
+                      <a:headEnd type="none" w="med" len="med"/>
+                      <a:tailEnd type="none" w="med" len="med"/>
+                    </a:lnT>
+                    <a:lnB w="9525" cap="flat" cmpd="sng" algn="ctr">
+                      <a:solidFill>
+                        <a:srgbClr val="D5E0E3"/>
+                      </a:solidFill>
+                      <a:prstDash val="solid"/>
+                      <a:round/>
+                      <a:headEnd type="none" w="med" len="med"/>
+                      <a:tailEnd type="none" w="med" len="med"/>
+                    </a:lnB>
+                    <a:solidFill>
+                      <a:srgbClr val="FFFFFF"/>
+                    </a:solidFill>
+                  </a:tcPr>
+                </a:tc>
+                <a:tc>
+                  <a:txBody>
+                    <a:bodyPr/>
+                    <a:lstStyle/>
+                    <a:p>
+                      <a:pPr algn="r" indent="0" marL="0">
+                        <a:buNone/>
+                      </a:pPr>
+                      <a:r>
+                        <a:rPr lang="en-US" sz="1300" dirty="0">
+                          <a:solidFill>
+                            <a:srgbClr val="17232E"/>
+                          </a:solidFill>
+                        </a:rPr>
+                        <a:t>$0</a:t>
+                      </a:r>
+                      <a:endParaRPr lang="en-US" sz="1300" dirty="0"/>
+                    </a:p>
+                  </a:txBody>
+                  <a:tcPr marL="73152" marR="73152" marT="27432" marB="27432" anchor="ctr">
+                    <a:lnL w="9525" cap="flat" cmpd="sng" algn="ctr">
+                      <a:solidFill>
+                        <a:srgbClr val="D5E0E3"/>
+                      </a:solidFill>
+                      <a:prstDash val="solid"/>
+                      <a:round/>
+                      <a:headEnd type="none" w="med" len="med"/>
+                      <a:tailEnd type="none" w="med" len="med"/>
+                    </a:lnL>
+                    <a:lnR w="9525" cap="flat" cmpd="sng" algn="ctr">
+                      <a:solidFill>
+                        <a:srgbClr val="D5E0E3"/>
+                      </a:solidFill>
+                      <a:prstDash val="solid"/>
+                      <a:round/>
+                      <a:headEnd type="none" w="med" len="med"/>
+                      <a:tailEnd type="none" w="med" len="med"/>
+                    </a:lnR>
+                    <a:lnT w="9525" cap="flat" cmpd="sng" algn="ctr">
+                      <a:solidFill>
+                        <a:srgbClr val="D5E0E3"/>
+                      </a:solidFill>
+                      <a:prstDash val="solid"/>
+                      <a:round/>
+                      <a:headEnd type="none" w="med" len="med"/>
+                      <a:tailEnd type="none" w="med" len="med"/>
+                    </a:lnT>
+                    <a:lnB w="9525" cap="flat" cmpd="sng" algn="ctr">
+                      <a:solidFill>
+                        <a:srgbClr val="D5E0E3"/>
+                      </a:solidFill>
+                      <a:prstDash val="solid"/>
+                      <a:round/>
+                      <a:headEnd type="none" w="med" len="med"/>
+                      <a:tailEnd type="none" w="med" len="med"/>
+                    </a:lnB>
+                    <a:solidFill>
+                      <a:srgbClr val="FFFFFF"/>
+                    </a:solidFill>
+                  </a:tcPr>
+                </a:tc>
+              </a:tr>
+              <a:tr h="457200">
+                <a:tc>
+                  <a:txBody>
+                    <a:bodyPr/>
+                    <a:lstStyle/>
+                    <a:p>
+                      <a:pPr algn="l" indent="0" marL="0">
+                        <a:buNone/>
+                      </a:pPr>
+                      <a:r>
+                        <a:rPr lang="en-US" sz="1300" b="1" dirty="0">
+                          <a:solidFill>
+                            <a:srgbClr val="17232E"/>
+                          </a:solidFill>
+                        </a:rPr>
+                        <a:t>Total</a:t>
+                      </a:r>
+                      <a:endParaRPr lang="en-US" sz="1300" dirty="0"/>
+                    </a:p>
+                  </a:txBody>
+                  <a:tcPr marL="73152" marR="73152" marT="27432" marB="27432" anchor="ctr">
+                    <a:lnL w="9525" cap="flat" cmpd="sng" algn="ctr">
+                      <a:solidFill>
+                        <a:srgbClr val="D5E0E3"/>
+                      </a:solidFill>
+                      <a:prstDash val="solid"/>
+                      <a:round/>
+                      <a:headEnd type="none" w="med" len="med"/>
+                      <a:tailEnd type="none" w="med" len="med"/>
+                    </a:lnL>
+                    <a:lnR w="9525" cap="flat" cmpd="sng" algn="ctr">
+                      <a:solidFill>
+                        <a:srgbClr val="D5E0E3"/>
+                      </a:solidFill>
+                      <a:prstDash val="solid"/>
+                      <a:round/>
+                      <a:headEnd type="none" w="med" len="med"/>
+                      <a:tailEnd type="none" w="med" len="med"/>
+                    </a:lnR>
+                    <a:lnT w="9525" cap="flat" cmpd="sng" algn="ctr">
+                      <a:solidFill>
+                        <a:srgbClr val="D5E0E3"/>
+                      </a:solidFill>
+                      <a:prstDash val="solid"/>
+                      <a:round/>
+                      <a:headEnd type="none" w="med" len="med"/>
+                      <a:tailEnd type="none" w="med" len="med"/>
+                    </a:lnT>
+                    <a:lnB w="9525" cap="flat" cmpd="sng" algn="ctr">
+                      <a:solidFill>
+                        <a:srgbClr val="D5E0E3"/>
+                      </a:solidFill>
+                      <a:prstDash val="solid"/>
+                      <a:round/>
+                      <a:headEnd type="none" w="med" len="med"/>
+                      <a:tailEnd type="none" w="med" len="med"/>
+                    </a:lnB>
+                    <a:solidFill>
+                      <a:srgbClr val="E1F2EF"/>
+                    </a:solidFill>
+                  </a:tcPr>
+                </a:tc>
+                <a:tc>
+                  <a:txBody>
+                    <a:bodyPr/>
+                    <a:lstStyle/>
+                    <a:p>
+                      <a:pPr algn="l" indent="0" marL="0">
+                        <a:buNone/>
+                      </a:pPr>
+                      <a:endParaRPr lang="en-US" sz="1300" dirty="0"/>
+                    </a:p>
+                  </a:txBody>
+                  <a:tcPr marL="73152" marR="73152" marT="27432" marB="27432" anchor="ctr">
+                    <a:lnL w="9525" cap="flat" cmpd="sng" algn="ctr">
+                      <a:solidFill>
+                        <a:srgbClr val="D5E0E3"/>
+                      </a:solidFill>
+                      <a:prstDash val="solid"/>
+                      <a:round/>
+                      <a:headEnd type="none" w="med" len="med"/>
+                      <a:tailEnd type="none" w="med" len="med"/>
+                    </a:lnL>
+                    <a:lnR w="9525" cap="flat" cmpd="sng" algn="ctr">
+                      <a:solidFill>
+                        <a:srgbClr val="D5E0E3"/>
+                      </a:solidFill>
+                      <a:prstDash val="solid"/>
+                      <a:round/>
+                      <a:headEnd type="none" w="med" len="med"/>
+                      <a:tailEnd type="none" w="med" len="med"/>
+                    </a:lnR>
+                    <a:lnT w="9525" cap="flat" cmpd="sng" algn="ctr">
+                      <a:solidFill>
+                        <a:srgbClr val="D5E0E3"/>
+                      </a:solidFill>
+                      <a:prstDash val="solid"/>
+                      <a:round/>
+                      <a:headEnd type="none" w="med" len="med"/>
+                      <a:tailEnd type="none" w="med" len="med"/>
+                    </a:lnT>
+                    <a:lnB w="9525" cap="flat" cmpd="sng" algn="ctr">
+                      <a:solidFill>
+                        <a:srgbClr val="D5E0E3"/>
+                      </a:solidFill>
+                      <a:prstDash val="solid"/>
+                      <a:round/>
+                      <a:headEnd type="none" w="med" len="med"/>
+                      <a:tailEnd type="none" w="med" len="med"/>
+                    </a:lnB>
+                    <a:solidFill>
+                      <a:srgbClr val="E1F2EF"/>
+                    </a:solidFill>
+                  </a:tcPr>
+                </a:tc>
+                <a:tc>
+                  <a:txBody>
+                    <a:bodyPr/>
+                    <a:lstStyle/>
+                    <a:p>
+                      <a:pPr algn="r" indent="0" marL="0">
+                        <a:buNone/>
+                      </a:pPr>
+                      <a:r>
+                        <a:rPr lang="en-US" sz="1300" b="1" dirty="0">
+                          <a:solidFill>
+                            <a:srgbClr val="17232E"/>
+                          </a:solidFill>
+                        </a:rPr>
+                        <a:t>$29,600</a:t>
+                      </a:r>
+                      <a:endParaRPr lang="en-US" sz="1300" dirty="0"/>
+                    </a:p>
+                  </a:txBody>
+                  <a:tcPr marL="73152" marR="73152" marT="27432" marB="27432" anchor="ctr">
+                    <a:lnL w="9525" cap="flat" cmpd="sng" algn="ctr">
+                      <a:solidFill>
+                        <a:srgbClr val="D5E0E3"/>
+                      </a:solidFill>
+                      <a:prstDash val="solid"/>
+                      <a:round/>
+                      <a:headEnd type="none" w="med" len="med"/>
+                      <a:tailEnd type="none" w="med" len="med"/>
+                    </a:lnL>
+                    <a:lnR w="9525" cap="flat" cmpd="sng" algn="ctr">
+                      <a:solidFill>
+                        <a:srgbClr val="D5E0E3"/>
+                      </a:solidFill>
+                      <a:prstDash val="solid"/>
+                      <a:round/>
+                      <a:headEnd type="none" w="med" len="med"/>
+                      <a:tailEnd type="none" w="med" len="med"/>
+                    </a:lnR>
+                    <a:lnT w="9525" cap="flat" cmpd="sng" algn="ctr">
+                      <a:solidFill>
+                        <a:srgbClr val="D5E0E3"/>
+                      </a:solidFill>
+                      <a:prstDash val="solid"/>
+                      <a:round/>
+                      <a:headEnd type="none" w="med" len="med"/>
+                      <a:tailEnd type="none" w="med" len="med"/>
+                    </a:lnT>
+                    <a:lnB w="9525" cap="flat" cmpd="sng" algn="ctr">
+                      <a:solidFill>
+                        <a:srgbClr val="D5E0E3"/>
+                      </a:solidFill>
+                      <a:prstDash val="solid"/>
+                      <a:round/>
+                      <a:headEnd type="none" w="med" len="med"/>
+                      <a:tailEnd type="none" w="med" len="med"/>
+                    </a:lnB>
+                    <a:solidFill>
+                      <a:srgbClr val="E1F2EF"/>
+                    </a:solidFill>
+                  </a:tcPr>
+                </a:tc>
+                <a:tc>
+                  <a:txBody>
+                    <a:bodyPr/>
+                    <a:lstStyle/>
+                    <a:p>
+                      <a:pPr algn="r" indent="0" marL="0">
+                        <a:buNone/>
+                      </a:pPr>
+                      <a:r>
+                        <a:rPr lang="en-US" sz="1300" b="1" dirty="0">
+                          <a:solidFill>
+                            <a:srgbClr val="17232E"/>
+                          </a:solidFill>
+                        </a:rPr>
+                        <a:t>$9,520</a:t>
+                      </a:r>
+                      <a:endParaRPr lang="en-US" sz="1300" dirty="0"/>
+                    </a:p>
+                  </a:txBody>
+                  <a:tcPr marL="73152" marR="73152" marT="27432" marB="27432" anchor="ctr">
+                    <a:lnL w="9525" cap="flat" cmpd="sng" algn="ctr">
+                      <a:solidFill>
+                        <a:srgbClr val="D5E0E3"/>
+                      </a:solidFill>
+                      <a:prstDash val="solid"/>
+                      <a:round/>
+                      <a:headEnd type="none" w="med" len="med"/>
+                      <a:tailEnd type="none" w="med" len="med"/>
+                    </a:lnL>
+                    <a:lnR w="9525" cap="flat" cmpd="sng" algn="ctr">
+                      <a:solidFill>
+                        <a:srgbClr val="D5E0E3"/>
+                      </a:solidFill>
+                      <a:prstDash val="solid"/>
+                      <a:round/>
+                      <a:headEnd type="none" w="med" len="med"/>
+                      <a:tailEnd type="none" w="med" len="med"/>
+                    </a:lnR>
+                    <a:lnT w="9525" cap="flat" cmpd="sng" algn="ctr">
+                      <a:solidFill>
+                        <a:srgbClr val="D5E0E3"/>
+                      </a:solidFill>
+                      <a:prstDash val="solid"/>
+                      <a:round/>
+                      <a:headEnd type="none" w="med" len="med"/>
+                      <a:tailEnd type="none" w="med" len="med"/>
+                    </a:lnT>
+                    <a:lnB w="9525" cap="flat" cmpd="sng" algn="ctr">
+                      <a:solidFill>
+                        <a:srgbClr val="D5E0E3"/>
+                      </a:solidFill>
+                      <a:prstDash val="solid"/>
+                      <a:round/>
+                      <a:headEnd type="none" w="med" len="med"/>
+                      <a:tailEnd type="none" w="med" len="med"/>
+                    </a:lnB>
+                    <a:solidFill>
+                      <a:srgbClr val="E1F2EF"/>
+                    </a:solidFill>
+                  </a:tcPr>
+                </a:tc>
+              </a:tr>
+            </a:tbl>
+          </a:graphicData>
+        </a:graphic>
+      </p:graphicFrame>
+      <p:sp>
+        <p:nvSpPr>
+          <p:cNvPr id="5" name="Shape 2"/>
+          <p:cNvSpPr/>
+          <p:nvPr/>
+        </p:nvSpPr>
+        <p:spPr>
+          <a:xfrm>
+            <a:off x="8229600" y="1508760"/>
+            <a:ext cx="3383280" cy="4114800"/>
+          </a:xfrm>
+          <a:prstGeom prst="roundRect">
+            <a:avLst>
+              <a:gd name="adj" fmla="val 2703"/>
+            </a:avLst>
+          </a:prstGeom>
+          <a:solidFill>
+            <a:schemeClr val="bg1"/>
+          </a:solidFill>
+          <a:ln w="9525">
+            <a:solidFill>
+              <a:srgbClr val="D5E0E3"/>
+            </a:solidFill>
+            <a:prstDash val="solid"/>
+          </a:ln>
+          <a:effectLst>
+            <a:outerShdw sx="100000" sy="100000" kx="0" ky="0" algn="bl" rotWithShape="0" blurRad="101600" dist="25400" dir="5400000">
+              <a:srgbClr val="0F2A3A">
+                <a:alpha val="18000"/>
+              </a:srgbClr>
+            </a:outerShdw>
+          </a:effectLst>
+        </p:spPr>
+      </p:sp>
+      <p:sp>
+        <p:nvSpPr>
+          <p:cNvPr id="6" name="Text 3"/>
+          <p:cNvSpPr txBox="1"/>
+          <p:nvPr/>
+        </p:nvSpPr>
+        <p:spPr>
+          <a:xfrm>
+            <a:off x="8458200" y="1691640"/>
+            <a:ext cx="3017520" cy="365760"/>
+          </a:xfrm>
+          <a:prstGeom prst="rect">
+            <a:avLst/>
+          </a:prstGeom>
+          <a:noFill/>
+          <a:ln/>
+        </p:spPr>
+        <p:txBody>
+          <a:bodyPr wrap="square" lIns="0" tIns="0" rIns="0" bIns="0" rtlCol="0" anchor="ctr"/>
+          <a:lstStyle/>
+          <a:p>
+            <a:pPr indent="0" marL="0">
+              <a:buNone/>
+            </a:pPr>
+            <a:r>
+              <a:rPr lang="en-US" sz="1700" b="1" dirty="0">
+                <a:solidFill>
+                  <a:schemeClr val="accent1"/>
+                </a:solidFill>
+              </a:rPr>
+              <a:t>Before approval</a:t>
+            </a:r>
+            <a:endParaRPr lang="en-US" sz="1700" dirty="0"/>
+          </a:p>
+        </p:txBody>
+      </p:sp>
+      <p:sp>
+        <p:nvSpPr>
+          <p:cNvPr id="7" name="Text 4"/>
+          <p:cNvSpPr txBox="1"/>
+          <p:nvPr/>
+        </p:nvSpPr>
+        <p:spPr>
+          <a:xfrm>
+            <a:off x="8458200" y="2148840"/>
+            <a:ext cx="3017520" cy="3291840"/>
+          </a:xfrm>
+          <a:prstGeom prst="rect">
+            <a:avLst/>
+          </a:prstGeom>
+          <a:noFill/>
+          <a:ln/>
+        </p:spPr>
+        <p:txBody>
+          <a:bodyPr wrap="square" lIns="0" tIns="0" rIns="0" bIns="0" rtlCol="0" anchor="t"/>
+          <a:lstStyle/>
+          <a:p>
+            <a:pPr marL="342900" indent="-342900">
+              <a:spcAft>
+                <a:spcPts val="800"/>
+              </a:spcAft>
+              <a:buSzPct val="100000"/>
+              <a:buChar char="•"/>
+            </a:pPr>
+            <a:r>
+              <a:rPr lang="en-US" sz="1300" dirty="0">
+                <a:solidFill>
+                  <a:schemeClr val="accent5"/>
+                </a:solidFill>
+              </a:rPr>
+              <a:t>Replace the $40/h rate with our real loaded labour cost</a:t>
+            </a:r>
+            <a:endParaRPr lang="en-US" sz="1300" dirty="0"/>
+          </a:p>
+          <a:p>
+            <a:pPr marL="342900" indent="-342900">
+              <a:spcAft>
+                <a:spcPts val="800"/>
+              </a:spcAft>
+              <a:buSzPct val="100000"/>
+              <a:buChar char="•"/>
+            </a:pPr>
+            <a:r>
+              <a:rPr lang="en-US" sz="1300" dirty="0">
+                <a:solidFill>
+                  <a:schemeClr val="accent5"/>
+                </a:solidFill>
+              </a:rPr>
+              <a:t>Get a real quote for the security review and hosting</a:t>
+            </a:r>
+            <a:endParaRPr lang="en-US" sz="1300" dirty="0"/>
+          </a:p>
+          <a:p>
+            <a:pPr marL="342900" indent="-342900">
+              <a:spcAft>
+                <a:spcPts val="800"/>
+              </a:spcAft>
+              <a:buSzPct val="100000"/>
+              <a:buChar char="•"/>
+            </a:pPr>
+            <a:r>
+              <a:rPr lang="en-US" sz="1300" dirty="0">
+                <a:solidFill>
+                  <a:schemeClr val="accent5"/>
+                </a:solidFill>
+              </a:rPr>
+              <a:t>Name one internal owner for support (the vendor price includes theirs)</a:t>
+            </a:r>
+            <a:endParaRPr lang="en-US" sz="1300" dirty="0"/>
+          </a:p>
+          <a:p>
+            <a:pPr marL="342900" indent="-342900">
+              <a:spcAft>
+                <a:spcPts val="800"/>
+              </a:spcAft>
+              <a:buSzPct val="100000"/>
+              <a:buChar char="•"/>
+            </a:pPr>
+            <a:r>
+              <a:rPr lang="en-US" sz="1300" dirty="0">
+                <a:solidFill>
+                  <a:schemeClr val="accent5"/>
+                </a:solidFill>
+              </a:rPr>
+              <a:t>Confirm the vendor quote covers updates, support and data migration</a:t>
+            </a:r>
+            <a:endParaRPr lang="en-US" sz="1300" dirty="0"/>
+          </a:p>
+        </p:txBody>
+      </p:sp>
+      <p:sp>
+        <p:nvSpPr>
+          <p:cNvPr id="8" name="Text 5"/>
+          <p:cNvSpPr txBox="1"/>
+          <p:nvPr/>
+        </p:nvSpPr>
+        <p:spPr>
+          <a:xfrm>
+            <a:off x="548640" y="6108192"/>
+            <a:ext cx="11064240" cy="274320"/>
+          </a:xfrm>
+          <a:prstGeom prst="rect">
+            <a:avLst/>
+          </a:prstGeom>
+          <a:noFill/>
+          <a:ln/>
+        </p:spPr>
+        <p:txBody>
+          <a:bodyPr wrap="square" lIns="0" tIns="0" rIns="0" bIns="0" rtlCol="0" anchor="ctr"/>
+          <a:lstStyle/>
+          <a:p>
+            <a:pPr indent="0" marL="0">
+              <a:buNone/>
+            </a:pPr>
+            <a:r>
+              <a:rPr lang="en-US" sz="1000" i="1" dirty="0">
+                <a:solidFill>
+                  <a:schemeClr val="accent5"/>
+                </a:solidFill>
+              </a:rPr>
+              <a:t>All MachineCare amounts are planning assumptions, not quotes. Editable model: docs/budget/MachineCare_Cost_Comparison.xlsx.</a:t>
+            </a:r>
+            <a:endParaRPr lang="en-US" sz="1000" dirty="0"/>
+          </a:p>
+        </p:txBody>
+      </p:sp>
+      <p:sp>
+        <p:nvSpPr>
+          <p:cNvPr id="25" name="Slide Number Placeholder 0"/>
+          <p:cNvSpPr>
+            <a:spLocks noGrp="1"/>
+          </p:cNvSpPr>
+          <p:nvPr>
+            <p:ph type="sldNum" sz="quarter" idx="4294967295"/>
+          </p:nvPr>
+        </p:nvSpPr>
+        <p:spPr>
+          <a:xfrm>
+            <a:off x="11155680" y="6446520"/>
+            <a:ext cx="457200" cy="228600"/>
+          </a:xfrm>
+          <a:prstGeom prst="rect">
+            <a:avLst/>
+          </a:prstGeom>
+          <a:extLst>
+            <a:ext uri="{C572A759-6A51-4108-AA02-DFA0A04FC94B}">
+              <ma14:wrappingTextBoxFlag xmlns:ma14="http://schemas.microsoft.com/office/mac/drawingml/2011/main" val="0"/>
+            </a:ext>
+          </a:extLst>
+        </p:spPr>
+        <p:txBody>
+          <a:bodyPr/>
+          <a:lstStyle>
+            <a:lvl1pPr>
+              <a:defRPr sz="1000">
+                <a:solidFill>
+                  <a:schemeClr val="accent5"/>
+                </a:solidFill>
+              </a:defRPr>
+            </a:lvl1pPr>
+          </a:lstStyle>
+          <a:p>
+            <a:pPr algn="r"/>
+            <a:fld id="{F7021451-1387-4CA6-816F-3879F97B5CBC}" type="slidenum">
+              <a:rPr b="0" lang="en-US"/>
+              <a:t>20</a:t>
+            </a:fld>
+            <a:endParaRPr lang="en-US"/>
+          </a:p>
+        </p:txBody>
+      </p:sp>
+    </p:spTree>
+  </p:cSld>
+  <p:clrMapOvr>
+    <a:masterClrMapping/>
+  </p:clrMapOvr>
+</p:sld>
+</file>
+
+<file path=ppt/slides/slide21.xml><?xml version="1.0" encoding="utf-8"?>
+<p:sld xmlns:a="http://schemas.openxmlformats.org/drawingml/2006/main" xmlns:r="http://schemas.openxmlformats.org/officeDocument/2006/relationships" xmlns:p="http://schemas.openxmlformats.org/presentationml/2006/main">
+  <p:cSld name="Slide 21">
+    <p:spTree>
+      <p:nvGrpSpPr>
+        <p:cNvPr id="1" name=""/>
+        <p:cNvGrpSpPr/>
+        <p:nvPr/>
+      </p:nvGrpSpPr>
+      <p:grpSpPr>
+        <a:xfrm>
+          <a:off x="0" y="0"/>
+          <a:ext cx="0" cy="0"/>
+          <a:chOff x="0" y="0"/>
+          <a:chExt cx="0" cy="0"/>
+        </a:xfrm>
+      </p:grpSpPr>
+      <p:sp>
+        <p:nvSpPr>
+          <p:cNvPr id="2" name="Text 0"/>
+          <p:cNvSpPr/>
+          <p:nvPr>
+            <p:ph idx="100" type="body" hasCustomPrompt="1"/>
+          </p:nvPr>
+        </p:nvSpPr>
+        <p:spPr>
+          <a:xfrm>
+            <a:off x="548640" y="457200"/>
+            <a:ext cx="11064240" cy="274320"/>
+          </a:xfrm>
+          <a:prstGeom prst="rect">
+            <a:avLst/>
+          </a:prstGeom>
+          <a:noFill/>
+          <a:ln/>
+        </p:spPr>
+        <p:txBody>
+          <a:bodyPr wrap="square" lIns="0" tIns="0" rIns="0" bIns="0" rtlCol="0"/>
+          <a:lstStyle/>
+          <a:p>
+            <a:pPr indent="0" marL="0">
+              <a:buNone/>
+            </a:pPr>
+            <a:r>
+              <a:rPr lang="en-US" sz="1200" b="1" spc="200" kern="0" dirty="0">
+                <a:solidFill>
+                  <a:schemeClr val="accent2"/>
+                </a:solidFill>
+              </a:rPr>
+              <a:t>THE DECISION</a:t>
+            </a:r>
+            <a:endParaRPr lang="en-US" sz="1200" dirty="0"/>
+          </a:p>
+        </p:txBody>
+      </p:sp>
+      <p:sp>
+        <p:nvSpPr>
+          <p:cNvPr id="3" name="Text 0"/>
+          <p:cNvSpPr/>
+          <p:nvPr>
+            <p:ph idx="101" type="title" hasCustomPrompt="1"/>
+          </p:nvPr>
+        </p:nvSpPr>
+        <p:spPr>
+          <a:xfrm>
+            <a:off x="548640" y="777240"/>
+            <a:ext cx="11064240" cy="914400"/>
+          </a:xfrm>
+          <a:prstGeom prst="rect">
+            <a:avLst/>
+          </a:prstGeom>
+          <a:noFill/>
+          <a:ln/>
+        </p:spPr>
+        <p:txBody>
+          <a:bodyPr wrap="square" lIns="0" tIns="0" rIns="0" bIns="0" rtlCol="0" anchor="t"/>
+          <a:lstStyle/>
+          <a:p>
+            <a:pPr algn="l" indent="0" marL="0">
+              <a:buNone/>
+            </a:pPr>
+            <a:r>
+              <a:rPr lang="en-US" sz="3600" b="1" dirty="0">
+                <a:solidFill>
+                  <a:schemeClr val="bg1"/>
+                </a:solidFill>
+              </a:rPr>
+              <a:t>Approve a focused validation pilot</a:t>
+            </a:r>
+            <a:endParaRPr lang="en-US" sz="3600" dirty="0"/>
+          </a:p>
+        </p:txBody>
+      </p:sp>
+      <p:sp>
+        <p:nvSpPr>
+          <p:cNvPr id="4" name="Shape 2"/>
+          <p:cNvSpPr/>
+          <p:nvPr/>
+        </p:nvSpPr>
+        <p:spPr>
+          <a:xfrm>
+            <a:off x="548640" y="2103120"/>
+            <a:ext cx="731520" cy="731520"/>
+          </a:xfrm>
+          <a:prstGeom prst="ellipse">
+            <a:avLst/>
+          </a:prstGeom>
+          <a:solidFill>
+            <a:schemeClr val="accent1"/>
+          </a:solidFill>
+          <a:ln/>
+        </p:spPr>
+      </p:sp>
+      <p:sp>
+        <p:nvSpPr>
+          <p:cNvPr id="5" name="Text 3"/>
+          <p:cNvSpPr txBox="1"/>
+          <p:nvPr/>
+        </p:nvSpPr>
+        <p:spPr>
+          <a:xfrm>
+            <a:off x="548640" y="2103120"/>
+            <a:ext cx="731520" cy="731520"/>
+          </a:xfrm>
+          <a:prstGeom prst="rect">
+            <a:avLst/>
+          </a:prstGeom>
+          <a:noFill/>
+          <a:ln/>
+        </p:spPr>
+        <p:txBody>
+          <a:bodyPr wrap="square" lIns="0" tIns="0" rIns="0" bIns="0" rtlCol="0" anchor="ctr"/>
+          <a:lstStyle/>
+          <a:p>
+            <a:pPr algn="ctr" indent="0" marL="0">
+              <a:buNone/>
+            </a:pPr>
+            <a:r>
+              <a:rPr lang="en-US" sz="2400" b="1" dirty="0">
+                <a:solidFill>
+                  <a:schemeClr val="bg1"/>
+                </a:solidFill>
+              </a:rPr>
+              <a:t>1</a:t>
+            </a:r>
+            <a:endParaRPr lang="en-US" sz="2400" dirty="0"/>
+          </a:p>
+        </p:txBody>
+      </p:sp>
+      <p:sp>
+        <p:nvSpPr>
+          <p:cNvPr id="6" name="Text 4"/>
+          <p:cNvSpPr txBox="1"/>
+          <p:nvPr/>
+        </p:nvSpPr>
+        <p:spPr>
+          <a:xfrm>
+            <a:off x="1554480" y="2057400"/>
+            <a:ext cx="6858000" cy="914400"/>
+          </a:xfrm>
+          <a:prstGeom prst="rect">
+            <a:avLst/>
+          </a:prstGeom>
+          <a:noFill/>
+          <a:ln/>
+        </p:spPr>
+        <p:txBody>
+          <a:bodyPr wrap="square" lIns="0" tIns="0" rIns="0" bIns="0" rtlCol="0" anchor="ctr"/>
+          <a:lstStyle/>
+          <a:p>
+            <a:pPr indent="0" marL="0">
+              <a:buNone/>
+            </a:pPr>
+            <a:r>
+              <a:rPr lang="en-US" sz="2200" b="1" dirty="0">
+                <a:solidFill>
+                  <a:schemeClr val="bg1"/>
+                </a:solidFill>
+              </a:rPr>
+              <a:t>Choose one validated line</a:t>
+            </a:r>
+            <a:endParaRPr lang="en-US" sz="2200" dirty="0"/>
+          </a:p>
+          <a:p>
+            <a:pPr indent="0" marL="0">
+              <a:buNone/>
+            </a:pPr>
+            <a:r>
+              <a:rPr lang="en-US" sz="1500" dirty="0">
+                <a:solidFill>
+                  <a:schemeClr val="accent6"/>
+                </a:solidFill>
+              </a:rPr>
+              <a:t>Where we count real stock and run the full workflow</a:t>
+            </a:r>
+            <a:endParaRPr lang="en-US" sz="2200" dirty="0"/>
+          </a:p>
+        </p:txBody>
+      </p:sp>
+      <p:sp>
+        <p:nvSpPr>
+          <p:cNvPr id="7" name="Shape 5"/>
+          <p:cNvSpPr/>
+          <p:nvPr/>
+        </p:nvSpPr>
+        <p:spPr>
+          <a:xfrm>
+            <a:off x="548640" y="3291840"/>
+            <a:ext cx="731520" cy="731520"/>
+          </a:xfrm>
+          <a:prstGeom prst="ellipse">
+            <a:avLst/>
+          </a:prstGeom>
+          <a:solidFill>
+            <a:schemeClr val="accent1"/>
+          </a:solidFill>
+          <a:ln/>
+        </p:spPr>
+      </p:sp>
+      <p:sp>
+        <p:nvSpPr>
+          <p:cNvPr id="8" name="Text 6"/>
+          <p:cNvSpPr txBox="1"/>
+          <p:nvPr/>
+        </p:nvSpPr>
+        <p:spPr>
+          <a:xfrm>
+            <a:off x="548640" y="3291840"/>
+            <a:ext cx="731520" cy="731520"/>
+          </a:xfrm>
+          <a:prstGeom prst="rect">
+            <a:avLst/>
+          </a:prstGeom>
+          <a:noFill/>
+          <a:ln/>
+        </p:spPr>
+        <p:txBody>
+          <a:bodyPr wrap="square" lIns="0" tIns="0" rIns="0" bIns="0" rtlCol="0" anchor="ctr"/>
+          <a:lstStyle/>
+          <a:p>
+            <a:pPr algn="ctr" indent="0" marL="0">
+              <a:buNone/>
+            </a:pPr>
+            <a:r>
+              <a:rPr lang="en-US" sz="2400" b="1" dirty="0">
+                <a:solidFill>
+                  <a:schemeClr val="bg1"/>
+                </a:solidFill>
+              </a:rPr>
+              <a:t>2</a:t>
+            </a:r>
+            <a:endParaRPr lang="en-US" sz="2400" dirty="0"/>
+          </a:p>
+        </p:txBody>
+      </p:sp>
+      <p:sp>
+        <p:nvSpPr>
+          <p:cNvPr id="9" name="Text 7"/>
+          <p:cNvSpPr txBox="1"/>
+          <p:nvPr/>
+        </p:nvSpPr>
+        <p:spPr>
+          <a:xfrm>
+            <a:off x="1554480" y="3246120"/>
+            <a:ext cx="6858000" cy="914400"/>
+          </a:xfrm>
+          <a:prstGeom prst="rect">
+            <a:avLst/>
+          </a:prstGeom>
+          <a:noFill/>
+          <a:ln/>
+        </p:spPr>
+        <p:txBody>
+          <a:bodyPr wrap="square" lIns="0" tIns="0" rIns="0" bIns="0" rtlCol="0" anchor="ctr"/>
+          <a:lstStyle/>
+          <a:p>
+            <a:pPr indent="0" marL="0">
+              <a:buNone/>
+            </a:pPr>
+            <a:r>
+              <a:rPr lang="en-US" sz="2200" b="1" dirty="0">
+                <a:solidFill>
+                  <a:schemeClr val="bg1"/>
+                </a:solidFill>
+              </a:rPr>
+              <a:t>Name a data owner and an IT reviewer</a:t>
+            </a:r>
+            <a:endParaRPr lang="en-US" sz="2200" dirty="0"/>
+          </a:p>
+          <a:p>
+            <a:pPr indent="0" marL="0">
+              <a:buNone/>
+            </a:pPr>
+            <a:r>
+              <a:rPr lang="en-US" sz="1500" dirty="0">
+                <a:solidFill>
+                  <a:schemeClr val="accent6"/>
+                </a:solidFill>
+              </a:rPr>
+              <a:t>Maintenance and IT/security owners for the production gates</a:t>
+            </a:r>
+            <a:endParaRPr lang="en-US" sz="2200" dirty="0"/>
+          </a:p>
+        </p:txBody>
+      </p:sp>
+      <p:sp>
+        <p:nvSpPr>
+          <p:cNvPr id="10" name="Shape 8"/>
+          <p:cNvSpPr/>
+          <p:nvPr/>
+        </p:nvSpPr>
+        <p:spPr>
+          <a:xfrm>
+            <a:off x="548640" y="4480560"/>
+            <a:ext cx="731520" cy="731520"/>
+          </a:xfrm>
+          <a:prstGeom prst="ellipse">
+            <a:avLst/>
+          </a:prstGeom>
+          <a:solidFill>
+            <a:schemeClr val="accent1"/>
+          </a:solidFill>
+          <a:ln/>
+        </p:spPr>
+      </p:sp>
+      <p:sp>
+        <p:nvSpPr>
+          <p:cNvPr id="11" name="Text 9"/>
+          <p:cNvSpPr txBox="1"/>
+          <p:nvPr/>
+        </p:nvSpPr>
+        <p:spPr>
+          <a:xfrm>
+            <a:off x="548640" y="4480560"/>
+            <a:ext cx="731520" cy="731520"/>
+          </a:xfrm>
+          <a:prstGeom prst="rect">
+            <a:avLst/>
+          </a:prstGeom>
+          <a:noFill/>
+          <a:ln/>
+        </p:spPr>
+        <p:txBody>
+          <a:bodyPr wrap="square" lIns="0" tIns="0" rIns="0" bIns="0" rtlCol="0" anchor="ctr"/>
+          <a:lstStyle/>
+          <a:p>
+            <a:pPr algn="ctr" indent="0" marL="0">
+              <a:buNone/>
+            </a:pPr>
+            <a:r>
+              <a:rPr lang="en-US" sz="2400" b="1" dirty="0">
+                <a:solidFill>
+                  <a:schemeClr val="bg1"/>
+                </a:solidFill>
+              </a:rPr>
+              <a:t>3</a:t>
+            </a:r>
+            <a:endParaRPr lang="en-US" sz="2400" dirty="0"/>
+          </a:p>
+        </p:txBody>
+      </p:sp>
+      <p:sp>
+        <p:nvSpPr>
+          <p:cNvPr id="12" name="Text 10"/>
+          <p:cNvSpPr txBox="1"/>
+          <p:nvPr/>
+        </p:nvSpPr>
+        <p:spPr>
+          <a:xfrm>
+            <a:off x="1554480" y="4434840"/>
+            <a:ext cx="6858000" cy="914400"/>
+          </a:xfrm>
+          <a:prstGeom prst="rect">
+            <a:avLst/>
+          </a:prstGeom>
+          <a:noFill/>
+          <a:ln/>
+        </p:spPr>
+        <p:txBody>
+          <a:bodyPr wrap="square" lIns="0" tIns="0" rIns="0" bIns="0" rtlCol="0" anchor="ctr"/>
+          <a:lstStyle/>
+          <a:p>
+            <a:pPr indent="0" marL="0">
+              <a:buNone/>
+            </a:pPr>
+            <a:r>
+              <a:rPr lang="en-US" sz="2200" b="1" dirty="0">
+                <a:solidFill>
+                  <a:schemeClr val="bg1"/>
+                </a:solidFill>
+              </a:rPr>
+              <a:t>Agree acceptance measures</a:t>
+            </a:r>
+            <a:endParaRPr lang="en-US" sz="2200" dirty="0"/>
+          </a:p>
+          <a:p>
+            <a:pPr indent="0" marL="0">
+              <a:buNone/>
+            </a:pPr>
+            <a:r>
+              <a:rPr lang="en-US" sz="1500" dirty="0">
+                <a:solidFill>
+                  <a:schemeClr val="accent6"/>
+                </a:solidFill>
+              </a:rPr>
+              <a:t>Traceability, stock accuracy and operator usability</a:t>
+            </a:r>
+            <a:endParaRPr lang="en-US" sz="2200" dirty="0"/>
+          </a:p>
+        </p:txBody>
+      </p:sp>
+      <p:pic>
+        <p:nvPicPr>
+          <p:cNvPr id="13" name="Image 0" descr="MachineCare on a phone-sized screen">    </p:cNvPr>
+          <p:cNvPicPr>
+            <a:picLocks noChangeAspect="1"/>
+          </p:cNvPicPr>
+          <p:nvPr/>
+        </p:nvPicPr>
+        <p:blipFill>
+          <a:blip r:embed="rId1"/>
+          <a:stretch>
+            <a:fillRect/>
+          </a:stretch>
+        </p:blipFill>
+        <p:spPr>
+          <a:xfrm>
+            <a:off x="9326880" y="1280160"/>
+            <a:ext cx="1737360" cy="3636335"/>
+          </a:xfrm>
+          <a:prstGeom prst="rect">
+            <a:avLst/>
+          </a:prstGeom>
+        </p:spPr>
+      </p:pic>
+      <p:sp>
+        <p:nvSpPr>
+          <p:cNvPr id="14" name="Text 11"/>
+          <p:cNvSpPr txBox="1"/>
+          <p:nvPr/>
+        </p:nvSpPr>
+        <p:spPr>
+          <a:xfrm>
+            <a:off x="9052560" y="5029200"/>
+            <a:ext cx="2286000" cy="365760"/>
+          </a:xfrm>
+          <a:prstGeom prst="rect">
+            <a:avLst/>
+          </a:prstGeom>
+          <a:noFill/>
+          <a:ln/>
+        </p:spPr>
+        <p:txBody>
+          <a:bodyPr wrap="square" lIns="0" tIns="0" rIns="0" bIns="0" rtlCol="0" anchor="ctr"/>
+          <a:lstStyle/>
+          <a:p>
+            <a:pPr algn="ctr" indent="0" marL="0">
+              <a:buNone/>
+            </a:pPr>
+            <a:r>
+              <a:rPr lang="en-US" sz="1200" dirty="0">
+                <a:solidFill>
+                  <a:schemeClr val="accent6"/>
+                </a:solidFill>
+              </a:rPr>
+              <a:t>Also works on a phone</a:t>
+            </a:r>
+            <a:endParaRPr lang="en-US" sz="1200" dirty="0"/>
+          </a:p>
+        </p:txBody>
+      </p:sp>
+      <p:sp>
+        <p:nvSpPr>
+          <p:cNvPr id="15" name="Text 12"/>
+          <p:cNvSpPr txBox="1"/>
+          <p:nvPr/>
+        </p:nvSpPr>
+        <p:spPr>
+          <a:xfrm>
+            <a:off x="548640" y="5852160"/>
+            <a:ext cx="8229600" cy="457200"/>
+          </a:xfrm>
+          <a:prstGeom prst="rect">
+            <a:avLst/>
+          </a:prstGeom>
+          <a:noFill/>
+          <a:ln/>
+        </p:spPr>
+        <p:txBody>
+          <a:bodyPr wrap="square" lIns="0" tIns="0" rIns="0" bIns="0" rtlCol="0" anchor="ctr"/>
+          <a:lstStyle/>
+          <a:p>
+            <a:pPr indent="0" marL="0">
+              <a:buNone/>
+            </a:pPr>
+            <a:r>
+              <a:rPr lang="en-US" sz="1600" i="1" dirty="0">
+                <a:solidFill>
+                  <a:schemeClr val="accent2"/>
+                </a:solidFill>
+              </a:rPr>
+              <a:t>A working local pilot today. A controlled release after validation.</a:t>
+            </a:r>
+            <a:endParaRPr lang="en-US" sz="1600" dirty="0"/>
+          </a:p>
+        </p:txBody>
+      </p:sp>
+      <p:sp>
+        <p:nvSpPr>
+          <p:cNvPr id="25" name="Slide Number Placeholder 0"/>
+          <p:cNvSpPr>
+            <a:spLocks noGrp="1"/>
+          </p:cNvSpPr>
+          <p:nvPr>
+            <p:ph type="sldNum" sz="quarter" idx="4294967295"/>
+          </p:nvPr>
+        </p:nvSpPr>
+        <p:spPr>
+          <a:xfrm>
+            <a:off x="11155680" y="6446520"/>
+            <a:ext cx="457200" cy="228600"/>
+          </a:xfrm>
+          <a:prstGeom prst="rect">
+            <a:avLst/>
+          </a:prstGeom>
+          <a:extLst>
+            <a:ext uri="{C572A759-6A51-4108-AA02-DFA0A04FC94B}">
+              <ma14:wrappingTextBoxFlag xmlns:ma14="http://schemas.microsoft.com/office/mac/drawingml/2011/main" val="0"/>
+            </a:ext>
+          </a:extLst>
+        </p:spPr>
+        <p:txBody>
+          <a:bodyPr/>
+          <a:lstStyle>
+            <a:lvl1pPr>
+              <a:defRPr sz="1000">
+                <a:solidFill>
+                  <a:schemeClr val="accent2"/>
+                </a:solidFill>
+              </a:defRPr>
+            </a:lvl1pPr>
+          </a:lstStyle>
+          <a:p>
+            <a:pPr algn="r"/>
+            <a:fld id="{F7021451-1387-4CA6-816F-3879F97B5CBC}" type="slidenum">
+              <a:rPr b="0" lang="en-US"/>
+              <a:t>21</a:t>
+            </a:fld>
+            <a:endParaRPr lang="en-US"/>
+          </a:p>
+        </p:txBody>
+      </p:sp>
+    </p:spTree>
+  </p:cSld>
+  <p:clrMapOvr>
+    <a:masterClrMapping/>
+  </p:clrMapOvr>
+</p:sld>
+</file>
+
+<file path=ppt/slides/slide22.xml><?xml version="1.0" encoding="utf-8"?>
+<p:sld xmlns:a="http://schemas.openxmlformats.org/drawingml/2006/main" xmlns:r="http://schemas.openxmlformats.org/officeDocument/2006/relationships" xmlns:p="http://schemas.openxmlformats.org/presentationml/2006/main">
+  <p:cSld name="Slide 22">
+    <p:spTree>
+      <p:nvGrpSpPr>
+        <p:cNvPr id="1" name=""/>
+        <p:cNvGrpSpPr/>
+        <p:nvPr/>
+      </p:nvGrpSpPr>
+      <p:grpSpPr>
+        <a:xfrm>
+          <a:off x="0" y="0"/>
+          <a:ext cx="0" cy="0"/>
+          <a:chOff x="0" y="0"/>
+          <a:chExt cx="0" cy="0"/>
+        </a:xfrm>
+      </p:grpSpPr>
+      <p:sp>
+        <p:nvSpPr>
+          <p:cNvPr id="2" name="Text 0"/>
+          <p:cNvSpPr/>
+          <p:nvPr>
+            <p:ph idx="100" type="body" hasCustomPrompt="1"/>
+          </p:nvPr>
+        </p:nvSpPr>
+        <p:spPr>
+          <a:xfrm>
+            <a:off x="548640" y="292608"/>
+            <a:ext cx="11064240" cy="274320"/>
+          </a:xfrm>
+          <a:prstGeom prst="rect">
+            <a:avLst/>
+          </a:prstGeom>
+          <a:noFill/>
+          <a:ln/>
+        </p:spPr>
+        <p:txBody>
+          <a:bodyPr wrap="square" lIns="0" tIns="0" rIns="0" bIns="0" rtlCol="0"/>
+          <a:lstStyle/>
+          <a:p>
+            <a:pPr indent="0" marL="0">
+              <a:buNone/>
+            </a:pPr>
+            <a:r>
+              <a:rPr lang="en-US" sz="1200" b="1" spc="200" kern="0" dirty="0">
+                <a:solidFill>
+                  <a:schemeClr val="accent1"/>
+                </a:solidFill>
+              </a:rPr>
+              <a:t>APPENDIX A</a:t>
+            </a:r>
+            <a:endParaRPr lang="en-US" sz="1200" dirty="0"/>
+          </a:p>
+        </p:txBody>
+      </p:sp>
+      <p:sp>
+        <p:nvSpPr>
+          <p:cNvPr id="3" name="Text 0"/>
+          <p:cNvSpPr/>
+          <p:nvPr>
+            <p:ph idx="101" type="title" hasCustomPrompt="1"/>
+          </p:nvPr>
+        </p:nvSpPr>
+        <p:spPr>
+          <a:xfrm>
+            <a:off x="548640" y="548640"/>
+            <a:ext cx="11064240" cy="685800"/>
+          </a:xfrm>
+          <a:prstGeom prst="rect">
+            <a:avLst/>
+          </a:prstGeom>
+          <a:noFill/>
+          <a:ln/>
+        </p:spPr>
+        <p:txBody>
+          <a:bodyPr wrap="square" lIns="0" tIns="0" rIns="0" bIns="0" rtlCol="0" anchor="t"/>
+          <a:lstStyle/>
+          <a:p>
+            <a:pPr algn="l" indent="0" marL="0">
+              <a:buNone/>
+            </a:pPr>
+            <a:r>
+              <a:rPr lang="en-US" sz="3200" b="1" dirty="0">
+                <a:solidFill>
+                  <a:schemeClr val="tx2"/>
+                </a:solidFill>
+              </a:rPr>
               <a:t>DIMM press component reference</a:t>
             </a:r>
             <a:endParaRPr lang="en-US" sz="3200" dirty="0"/>
@@ -13214,7 +16995,7 @@
       </p:sp>
       <p:graphicFrame>
         <p:nvGraphicFramePr>
-          <p:cNvPr id="21" name="Table 0"/>
+          <p:cNvPr id="23" name="Table 0"/>
           <p:cNvGraphicFramePr>
             <a:graphicFrameLocks noGrp="1"/>
           </p:cNvGraphicFramePr>
@@ -15989,7 +19770,7 @@
             <a:pPr algn="r"/>
             <a:fld id="{F7021451-1387-4CA6-816F-3879F97B5CBC}" type="slidenum">
               <a:rPr b="0" lang="en-US"/>
-              <a:t>20</a:t>
+              <a:t>22</a:t>
             </a:fld>
             <a:endParaRPr lang="en-US"/>
           </a:p>
@@ -16003,9 +19784,9 @@
 </p:sld>
 </file>
 
-<file path=ppt/slides/slide21.xml><?xml version="1.0" encoding="utf-8"?>
+<file path=ppt/slides/slide23.xml><?xml version="1.0" encoding="utf-8"?>
 <p:sld xmlns:a="http://schemas.openxmlformats.org/drawingml/2006/main" xmlns:r="http://schemas.openxmlformats.org/officeDocument/2006/relationships" xmlns:p="http://schemas.openxmlformats.org/presentationml/2006/main">
-  <p:cSld name="Slide 21">
+  <p:cSld name="Slide 23">
     <p:spTree>
       <p:nvGrpSpPr>
         <p:cNvPr id="1" name=""/>
@@ -16098,7 +19879,7 @@
       </p:sp>
       <p:graphicFrame>
         <p:nvGraphicFramePr>
-          <p:cNvPr id="22" name="Table 0"/>
+          <p:cNvPr id="24" name="Table 0"/>
           <p:cNvGraphicFramePr>
             <a:graphicFrameLocks noGrp="1"/>
           </p:cNvGraphicFramePr>
@@ -18135,7 +21916,7 @@
             <a:pPr algn="r"/>
             <a:fld id="{F7021451-1387-4CA6-816F-3879F97B5CBC}" type="slidenum">
               <a:rPr b="0" lang="en-US"/>
-              <a:t>21</a:t>
+              <a:t>23</a:t>
             </a:fld>
             <a:endParaRPr lang="en-US"/>
           </a:p>
@@ -23986,7 +27767,7 @@
                   <a:schemeClr val="tx2"/>
                 </a:solidFill>
               </a:rPr>
-              <a:t>Real references kept</a:t>
+              <a:t>Supplier lead time</a:t>
             </a:r>
             <a:endParaRPr lang="en-US" sz="1400" dirty="0"/>
           </a:p>
@@ -24003,7 +27784,7 @@
                   <a:schemeClr val="accent5"/>
                 </a:solidFill>
               </a:rPr>
-              <a:t>Manufacturer, model or serial, and quantity per machine</a:t>
+              <a:t>Shown in weeks or months; long-lead parts are flagged and arrival is estimated</a:t>
             </a:r>
             <a:endParaRPr lang="en-US" sz="1400" dirty="0"/>
           </a:p>
@@ -24098,7 +27879,7 @@
                   <a:schemeClr val="tx2"/>
                 </a:solidFill>
               </a:rPr>
-              <a:t>Demo values flagged</a:t>
+              <a:t>Real references, honest labels</a:t>
             </a:r>
             <a:endParaRPr lang="en-US" sz="1400" dirty="0"/>
           </a:p>
@@ -24115,7 +27896,7 @@
                   <a:schemeClr val="accent5"/>
                 </a:solidFill>
               </a:rPr>
-              <a:t>A blue tag marks stock, prices, bins and intervals as placeholders</a:t>
+              <a:t>Supplied model or serial kept; a blue tag marks demo stock and prices</a:t>
             </a:r>
             <a:endParaRPr lang="en-US" sz="1400" dirty="0"/>
           </a:p>

</xml_diff>